<commit_message>
Agregar priorización MoSCoW + 100 puntos y ajustar el tablero Kanban
- Priorización (semana 5): las 12 historias de NewBit con MoSCoW
  (8 Must, 3 Should, 1 Could, 3 Won't del Acta) y el método de los
  100 puntos votado por los tres integrantes. PDF para el Drive,
  PPTX, HTML y generador.
- Tablero Kanban: orden de las Should según los 100 puntos
  (HU10, HU12, HU06), subtítulo y notas sin "propuesta", y su .md
  con el backlog completo.
- Índice y README del proyecto con las nuevas carpetas.

Co-Authored-By: Claude Opus 5.5 <noreply@anthropic.com>
</commit_message>
<xml_diff>
--- a/proyecto/entregables/semana-05/Tablero_Kanban_NewBit/Tablero_Kanban_NewBit.pptx
+++ b/proyecto/entregables/semana-05/Tablero_Kanban_NewBit/Tablero_Kanban_NewBit.pptx
@@ -595,7 +595,7 @@
           <a:p>
             <a:r>
               <a:rPr lang="en-US" dirty="0"/>
-              <a:t>Albert (PO). Las 12 historias del FGAP040 ordenadas por prioridad: valor, riesgo y dependencias (SBOK 8.5). Cada una tiene su prioridad MoSCoW, su estimación en puntos y el sprint donde entra. Total 31 puntos en 4 sprints. Es nuestra propuesta; la validamos votando con el puño de cinco.</a:t>
+              <a:t>Albert (PO). Las 12 historias del FGAP040 ordenadas por prioridad: MoSCoW, los 100 puntos y las dependencias (SBOK 8.5; ver la actividad de priorización). Cada una tiene su prioridad MoSCoW, su estimación en puntos y el sprint donde entra. Total 31 puntos en 4 sprints. La prioridad salió de MoSCoW y los 100 puntos; la estimación, del puño de cinco.</a:t>
             </a:r>
             <a:endParaRPr lang="en-US" dirty="0"/>
           </a:p>
@@ -2596,7 +2596,7 @@
                 <a:ea typeface="Calibri" pitchFamily="34" charset="-122"/>
                 <a:cs typeface="Calibri" pitchFamily="34" charset="-120"/>
               </a:rPr>
-              <a:t>12 historias · 31 puntos · 4 sprints de 2 semanas · propuesta del equipo para validar con el puño de cinco</a:t>
+              <a:t>12 historias · 31 puntos · 4 sprints de 2 semanas · priorizado con MoSCoW y 100 puntos · estimado con el puño de cinco</a:t>
             </a:r>
             <a:endParaRPr lang="en-US" sz="1200" dirty="0"/>
           </a:p>
@@ -7021,7 +7021,7 @@
                           <a:ea typeface="Calibri" pitchFamily="34" charset="-122"/>
                           <a:cs typeface="Calibri" pitchFamily="34" charset="-120"/>
                         </a:rPr>
-                        <a:t>HU06</a:t>
+                        <a:t>HU10</a:t>
                       </a:r>
                       <a:endParaRPr lang="en-US" sz="1100" dirty="0">
                         <a:latin typeface="Calibri" charset="0"/>
@@ -7089,7 +7089,7 @@
                           <a:ea typeface="Calibri" pitchFamily="34" charset="-122"/>
                           <a:cs typeface="Calibri" pitchFamily="34" charset="-120"/>
                         </a:rPr>
-                        <a:t>Descartar clips cortos</a:t>
+                        <a:t>Alerta insegura</a:t>
                       </a:r>
                       <a:endParaRPr lang="en-US" sz="1100" dirty="0">
                         <a:latin typeface="Calibri" charset="0"/>
@@ -7157,7 +7157,7 @@
                           <a:ea typeface="Calibri" pitchFamily="34" charset="-122"/>
                           <a:cs typeface="Calibri" pitchFamily="34" charset="-120"/>
                         </a:rPr>
-                        <a:t>EP03 · Segmentación temporal</a:t>
+                        <a:t>EP05 · GUI y validación</a:t>
                       </a:r>
                       <a:endParaRPr lang="en-US" sz="1100" dirty="0">
                         <a:latin typeface="Calibri" charset="0"/>
@@ -7361,7 +7361,7 @@
                           <a:ea typeface="Calibri" pitchFamily="34" charset="-122"/>
                           <a:cs typeface="Calibri" pitchFamily="34" charset="-120"/>
                         </a:rPr>
-                        <a:t>Sprint 2</a:t>
+                        <a:t>Sprint 4</a:t>
                       </a:r>
                       <a:endParaRPr lang="en-US" sz="1100" dirty="0">
                         <a:latin typeface="Calibri" charset="0"/>
@@ -7499,7 +7499,7 @@
                           <a:ea typeface="Calibri" pitchFamily="34" charset="-122"/>
                           <a:cs typeface="Calibri" pitchFamily="34" charset="-120"/>
                         </a:rPr>
-                        <a:t>HU10</a:t>
+                        <a:t>HU12</a:t>
                       </a:r>
                       <a:endParaRPr lang="en-US" sz="1100" dirty="0">
                         <a:latin typeface="Calibri" charset="0"/>
@@ -7567,7 +7567,7 @@
                           <a:ea typeface="Calibri" pitchFamily="34" charset="-122"/>
                           <a:cs typeface="Calibri" pitchFamily="34" charset="-120"/>
                         </a:rPr>
-                        <a:t>Alerta insegura</a:t>
+                        <a:t>Ver log de tiempos</a:t>
                       </a:r>
                       <a:endParaRPr lang="en-US" sz="1100" dirty="0">
                         <a:latin typeface="Calibri" charset="0"/>
@@ -7635,7 +7635,7 @@
                           <a:ea typeface="Calibri" pitchFamily="34" charset="-122"/>
                           <a:cs typeface="Calibri" pitchFamily="34" charset="-120"/>
                         </a:rPr>
-                        <a:t>EP05 · GUI y validación</a:t>
+                        <a:t>EP06 · Administración</a:t>
                       </a:r>
                       <a:endParaRPr lang="en-US" sz="1100" dirty="0">
                         <a:latin typeface="Calibri" charset="0"/>
@@ -7977,7 +7977,7 @@
                           <a:ea typeface="Calibri" pitchFamily="34" charset="-122"/>
                           <a:cs typeface="Calibri" pitchFamily="34" charset="-120"/>
                         </a:rPr>
-                        <a:t>HU12</a:t>
+                        <a:t>HU06</a:t>
                       </a:r>
                       <a:endParaRPr lang="en-US" sz="1100" dirty="0">
                         <a:latin typeface="Calibri" charset="0"/>
@@ -8045,7 +8045,7 @@
                           <a:ea typeface="Calibri" pitchFamily="34" charset="-122"/>
                           <a:cs typeface="Calibri" pitchFamily="34" charset="-120"/>
                         </a:rPr>
-                        <a:t>Ver log de tiempos</a:t>
+                        <a:t>Descartar clips cortos</a:t>
                       </a:r>
                       <a:endParaRPr lang="en-US" sz="1100" dirty="0">
                         <a:latin typeface="Calibri" charset="0"/>
@@ -8113,7 +8113,7 @@
                           <a:ea typeface="Calibri" pitchFamily="34" charset="-122"/>
                           <a:cs typeface="Calibri" pitchFamily="34" charset="-120"/>
                         </a:rPr>
-                        <a:t>EP06 · Administración</a:t>
+                        <a:t>EP03 · Segmentación temporal</a:t>
                       </a:r>
                       <a:endParaRPr lang="en-US" sz="1100" dirty="0">
                         <a:latin typeface="Calibri" charset="0"/>
@@ -8317,7 +8317,7 @@
                           <a:ea typeface="Calibri" pitchFamily="34" charset="-122"/>
                           <a:cs typeface="Calibri" pitchFamily="34" charset="-120"/>
                         </a:rPr>
-                        <a:t>Sprint 4</a:t>
+                        <a:t>Sprint 2</a:t>
                       </a:r>
                       <a:endParaRPr lang="en-US" sz="1100" dirty="0">
                         <a:latin typeface="Calibri" charset="0"/>
@@ -8959,7 +8959,7 @@
                 <a:ea typeface="Calibri" pitchFamily="34" charset="-122"/>
                 <a:cs typeface="Calibri" pitchFamily="34" charset="-120"/>
               </a:rPr>
-              <a:t>Criterios de aceptación · HU01 a HU06</a:t>
+              <a:t>Criterios de aceptación (1/2)</a:t>
             </a:r>
             <a:endParaRPr lang="en-US" sz="3000" dirty="0"/>
           </a:p>
@@ -8973,7 +8973,7 @@
         </p:nvSpPr>
         <p:spPr>
           <a:xfrm>
-            <a:off x="548640" y="914400"/>
+            <a:off x="548640" y="987552"/>
             <a:ext cx="8046720" cy="228600"/>
           </a:xfrm>
           <a:prstGeom prst="rect">
@@ -9012,7 +9012,7 @@
         </p:nvSpPr>
         <p:spPr>
           <a:xfrm>
-            <a:off x="548640" y="1234440"/>
+            <a:off x="548640" y="1298448"/>
             <a:ext cx="2560320" cy="1645920"/>
           </a:xfrm>
           <a:prstGeom prst="roundRect">
@@ -9034,7 +9034,7 @@
         </p:nvSpPr>
         <p:spPr>
           <a:xfrm>
-            <a:off x="694944" y="1417320"/>
+            <a:off x="694944" y="1481328"/>
             <a:ext cx="128016" cy="128016"/>
           </a:xfrm>
           <a:prstGeom prst="roundRect">
@@ -9056,7 +9056,7 @@
         </p:nvSpPr>
         <p:spPr>
           <a:xfrm>
-            <a:off x="896112" y="1362456"/>
+            <a:off x="896112" y="1426464"/>
             <a:ext cx="1143000" cy="237744"/>
           </a:xfrm>
           <a:prstGeom prst="rect">
@@ -9109,7 +9109,7 @@
         </p:nvSpPr>
         <p:spPr>
           <a:xfrm>
-            <a:off x="1938528" y="1380744"/>
+            <a:off x="1938528" y="1444752"/>
             <a:ext cx="566928" cy="201168"/>
           </a:xfrm>
           <a:prstGeom prst="roundRect">
@@ -9131,7 +9131,7 @@
         </p:nvSpPr>
         <p:spPr>
           <a:xfrm>
-            <a:off x="1938528" y="1380744"/>
+            <a:off x="1938528" y="1444752"/>
             <a:ext cx="566928" cy="201168"/>
           </a:xfrm>
           <a:prstGeom prst="rect">
@@ -9170,7 +9170,7 @@
         </p:nvSpPr>
         <p:spPr>
           <a:xfrm>
-            <a:off x="2560320" y="1380744"/>
+            <a:off x="2560320" y="1444752"/>
             <a:ext cx="402336" cy="201168"/>
           </a:xfrm>
           <a:prstGeom prst="roundRect">
@@ -9192,7 +9192,7 @@
         </p:nvSpPr>
         <p:spPr>
           <a:xfrm>
-            <a:off x="2560320" y="1380744"/>
+            <a:off x="2560320" y="1444752"/>
             <a:ext cx="402336" cy="201168"/>
           </a:xfrm>
           <a:prstGeom prst="rect">
@@ -9231,7 +9231,7 @@
         </p:nvSpPr>
         <p:spPr>
           <a:xfrm>
-            <a:off x="694944" y="1618488"/>
+            <a:off x="694944" y="1682496"/>
             <a:ext cx="2267712" cy="228600"/>
           </a:xfrm>
           <a:prstGeom prst="rect">
@@ -9270,8 +9270,8 @@
         </p:nvSpPr>
         <p:spPr>
           <a:xfrm>
-            <a:off x="694944" y="1856232"/>
-            <a:ext cx="2267712" cy="329184"/>
+            <a:off x="694944" y="1901952"/>
+            <a:ext cx="2267712" cy="310896"/>
           </a:xfrm>
           <a:prstGeom prst="rect">
             <a:avLst/>
@@ -9309,7 +9309,7 @@
         </p:nvSpPr>
         <p:spPr>
           <a:xfrm>
-            <a:off x="713232" y="2276856"/>
+            <a:off x="713232" y="2322576"/>
             <a:ext cx="64008" cy="64008"/>
           </a:xfrm>
           <a:prstGeom prst="roundRect">
@@ -9331,7 +9331,7 @@
         </p:nvSpPr>
         <p:spPr>
           <a:xfrm>
-            <a:off x="841248" y="2221992"/>
+            <a:off x="841248" y="2267712"/>
             <a:ext cx="2121408" cy="292608"/>
           </a:xfrm>
           <a:prstGeom prst="rect">
@@ -9370,7 +9370,7 @@
         </p:nvSpPr>
         <p:spPr>
           <a:xfrm>
-            <a:off x="713232" y="2587752"/>
+            <a:off x="713232" y="2642616"/>
             <a:ext cx="64008" cy="64008"/>
           </a:xfrm>
           <a:prstGeom prst="roundRect">
@@ -9392,7 +9392,7 @@
         </p:nvSpPr>
         <p:spPr>
           <a:xfrm>
-            <a:off x="841248" y="2532888"/>
+            <a:off x="841248" y="2587752"/>
             <a:ext cx="2121408" cy="292608"/>
           </a:xfrm>
           <a:prstGeom prst="rect">
@@ -9431,7 +9431,7 @@
         </p:nvSpPr>
         <p:spPr>
           <a:xfrm>
-            <a:off x="3291840" y="1234440"/>
+            <a:off x="3291840" y="1298448"/>
             <a:ext cx="2560320" cy="1645920"/>
           </a:xfrm>
           <a:prstGeom prst="roundRect">
@@ -9453,7 +9453,7 @@
         </p:nvSpPr>
         <p:spPr>
           <a:xfrm>
-            <a:off x="3438144" y="1417320"/>
+            <a:off x="3438144" y="1481328"/>
             <a:ext cx="128016" cy="128016"/>
           </a:xfrm>
           <a:prstGeom prst="roundRect">
@@ -9475,7 +9475,7 @@
         </p:nvSpPr>
         <p:spPr>
           <a:xfrm>
-            <a:off x="3639312" y="1362456"/>
+            <a:off x="3639312" y="1426464"/>
             <a:ext cx="1143000" cy="237744"/>
           </a:xfrm>
           <a:prstGeom prst="rect">
@@ -9528,7 +9528,7 @@
         </p:nvSpPr>
         <p:spPr>
           <a:xfrm>
-            <a:off x="4681728" y="1380744"/>
+            <a:off x="4681728" y="1444752"/>
             <a:ext cx="566928" cy="201168"/>
           </a:xfrm>
           <a:prstGeom prst="roundRect">
@@ -9550,7 +9550,7 @@
         </p:nvSpPr>
         <p:spPr>
           <a:xfrm>
-            <a:off x="4681728" y="1380744"/>
+            <a:off x="4681728" y="1444752"/>
             <a:ext cx="566928" cy="201168"/>
           </a:xfrm>
           <a:prstGeom prst="rect">
@@ -9589,7 +9589,7 @@
         </p:nvSpPr>
         <p:spPr>
           <a:xfrm>
-            <a:off x="5303520" y="1380744"/>
+            <a:off x="5303520" y="1444752"/>
             <a:ext cx="402336" cy="201168"/>
           </a:xfrm>
           <a:prstGeom prst="roundRect">
@@ -9611,7 +9611,7 @@
         </p:nvSpPr>
         <p:spPr>
           <a:xfrm>
-            <a:off x="5303520" y="1380744"/>
+            <a:off x="5303520" y="1444752"/>
             <a:ext cx="402336" cy="201168"/>
           </a:xfrm>
           <a:prstGeom prst="rect">
@@ -9650,7 +9650,7 @@
         </p:nvSpPr>
         <p:spPr>
           <a:xfrm>
-            <a:off x="3438144" y="1618488"/>
+            <a:off x="3438144" y="1682496"/>
             <a:ext cx="2267712" cy="228600"/>
           </a:xfrm>
           <a:prstGeom prst="rect">
@@ -9689,8 +9689,8 @@
         </p:nvSpPr>
         <p:spPr>
           <a:xfrm>
-            <a:off x="3438144" y="1856232"/>
-            <a:ext cx="2267712" cy="329184"/>
+            <a:off x="3438144" y="1901952"/>
+            <a:ext cx="2267712" cy="310896"/>
           </a:xfrm>
           <a:prstGeom prst="rect">
             <a:avLst/>
@@ -9728,7 +9728,7 @@
         </p:nvSpPr>
         <p:spPr>
           <a:xfrm>
-            <a:off x="3456432" y="2276856"/>
+            <a:off x="3456432" y="2322576"/>
             <a:ext cx="64008" cy="64008"/>
           </a:xfrm>
           <a:prstGeom prst="roundRect">
@@ -9750,7 +9750,7 @@
         </p:nvSpPr>
         <p:spPr>
           <a:xfrm>
-            <a:off x="3584448" y="2221992"/>
+            <a:off x="3584448" y="2267712"/>
             <a:ext cx="2121408" cy="292608"/>
           </a:xfrm>
           <a:prstGeom prst="rect">
@@ -9789,7 +9789,7 @@
         </p:nvSpPr>
         <p:spPr>
           <a:xfrm>
-            <a:off x="3456432" y="2587752"/>
+            <a:off x="3456432" y="2642616"/>
             <a:ext cx="64008" cy="64008"/>
           </a:xfrm>
           <a:prstGeom prst="roundRect">
@@ -9811,7 +9811,7 @@
         </p:nvSpPr>
         <p:spPr>
           <a:xfrm>
-            <a:off x="3584448" y="2532888"/>
+            <a:off x="3584448" y="2587752"/>
             <a:ext cx="2121408" cy="292608"/>
           </a:xfrm>
           <a:prstGeom prst="rect">
@@ -9850,7 +9850,7 @@
         </p:nvSpPr>
         <p:spPr>
           <a:xfrm>
-            <a:off x="6035040" y="1234440"/>
+            <a:off x="6035040" y="1298448"/>
             <a:ext cx="2560320" cy="1645920"/>
           </a:xfrm>
           <a:prstGeom prst="roundRect">
@@ -9872,7 +9872,7 @@
         </p:nvSpPr>
         <p:spPr>
           <a:xfrm>
-            <a:off x="6181344" y="1417320"/>
+            <a:off x="6181344" y="1481328"/>
             <a:ext cx="128016" cy="128016"/>
           </a:xfrm>
           <a:prstGeom prst="roundRect">
@@ -9894,7 +9894,7 @@
         </p:nvSpPr>
         <p:spPr>
           <a:xfrm>
-            <a:off x="6382512" y="1362456"/>
+            <a:off x="6382512" y="1426464"/>
             <a:ext cx="1143000" cy="237744"/>
           </a:xfrm>
           <a:prstGeom prst="rect">
@@ -9947,7 +9947,7 @@
         </p:nvSpPr>
         <p:spPr>
           <a:xfrm>
-            <a:off x="7424928" y="1380744"/>
+            <a:off x="7424928" y="1444752"/>
             <a:ext cx="566928" cy="201168"/>
           </a:xfrm>
           <a:prstGeom prst="roundRect">
@@ -9969,7 +9969,7 @@
         </p:nvSpPr>
         <p:spPr>
           <a:xfrm>
-            <a:off x="7424928" y="1380744"/>
+            <a:off x="7424928" y="1444752"/>
             <a:ext cx="566928" cy="201168"/>
           </a:xfrm>
           <a:prstGeom prst="rect">
@@ -10008,7 +10008,7 @@
         </p:nvSpPr>
         <p:spPr>
           <a:xfrm>
-            <a:off x="8046720" y="1380744"/>
+            <a:off x="8046720" y="1444752"/>
             <a:ext cx="402336" cy="201168"/>
           </a:xfrm>
           <a:prstGeom prst="roundRect">
@@ -10030,7 +10030,7 @@
         </p:nvSpPr>
         <p:spPr>
           <a:xfrm>
-            <a:off x="8046720" y="1380744"/>
+            <a:off x="8046720" y="1444752"/>
             <a:ext cx="402336" cy="201168"/>
           </a:xfrm>
           <a:prstGeom prst="rect">
@@ -10069,7 +10069,7 @@
         </p:nvSpPr>
         <p:spPr>
           <a:xfrm>
-            <a:off x="6181344" y="1618488"/>
+            <a:off x="6181344" y="1682496"/>
             <a:ext cx="2267712" cy="228600"/>
           </a:xfrm>
           <a:prstGeom prst="rect">
@@ -10108,8 +10108,8 @@
         </p:nvSpPr>
         <p:spPr>
           <a:xfrm>
-            <a:off x="6181344" y="1856232"/>
-            <a:ext cx="2267712" cy="329184"/>
+            <a:off x="6181344" y="1901952"/>
+            <a:ext cx="2267712" cy="310896"/>
           </a:xfrm>
           <a:prstGeom prst="rect">
             <a:avLst/>
@@ -10147,7 +10147,7 @@
         </p:nvSpPr>
         <p:spPr>
           <a:xfrm>
-            <a:off x="6199632" y="2276856"/>
+            <a:off x="6199632" y="2322576"/>
             <a:ext cx="64008" cy="64008"/>
           </a:xfrm>
           <a:prstGeom prst="roundRect">
@@ -10169,7 +10169,7 @@
         </p:nvSpPr>
         <p:spPr>
           <a:xfrm>
-            <a:off x="6327648" y="2221992"/>
+            <a:off x="6327648" y="2267712"/>
             <a:ext cx="2121408" cy="292608"/>
           </a:xfrm>
           <a:prstGeom prst="rect">
@@ -10208,7 +10208,7 @@
         </p:nvSpPr>
         <p:spPr>
           <a:xfrm>
-            <a:off x="6199632" y="2587752"/>
+            <a:off x="6199632" y="2642616"/>
             <a:ext cx="64008" cy="64008"/>
           </a:xfrm>
           <a:prstGeom prst="roundRect">
@@ -10230,7 +10230,7 @@
         </p:nvSpPr>
         <p:spPr>
           <a:xfrm>
-            <a:off x="6327648" y="2532888"/>
+            <a:off x="6327648" y="2587752"/>
             <a:ext cx="2121408" cy="292608"/>
           </a:xfrm>
           <a:prstGeom prst="rect">
@@ -10269,7 +10269,7 @@
         </p:nvSpPr>
         <p:spPr>
           <a:xfrm>
-            <a:off x="548640" y="2990088"/>
+            <a:off x="548640" y="2999232"/>
             <a:ext cx="2560320" cy="1645920"/>
           </a:xfrm>
           <a:prstGeom prst="roundRect">
@@ -10291,7 +10291,7 @@
         </p:nvSpPr>
         <p:spPr>
           <a:xfrm>
-            <a:off x="694944" y="3172968"/>
+            <a:off x="694944" y="3182112"/>
             <a:ext cx="128016" cy="128016"/>
           </a:xfrm>
           <a:prstGeom prst="roundRect">
@@ -10313,7 +10313,7 @@
         </p:nvSpPr>
         <p:spPr>
           <a:xfrm>
-            <a:off x="896112" y="3118104"/>
+            <a:off x="896112" y="3127248"/>
             <a:ext cx="1143000" cy="237744"/>
           </a:xfrm>
           <a:prstGeom prst="rect">
@@ -10366,7 +10366,7 @@
         </p:nvSpPr>
         <p:spPr>
           <a:xfrm>
-            <a:off x="1938528" y="3136392"/>
+            <a:off x="1938528" y="3145536"/>
             <a:ext cx="566928" cy="201168"/>
           </a:xfrm>
           <a:prstGeom prst="roundRect">
@@ -10388,7 +10388,7 @@
         </p:nvSpPr>
         <p:spPr>
           <a:xfrm>
-            <a:off x="1938528" y="3136392"/>
+            <a:off x="1938528" y="3145536"/>
             <a:ext cx="566928" cy="201168"/>
           </a:xfrm>
           <a:prstGeom prst="rect">
@@ -10427,7 +10427,7 @@
         </p:nvSpPr>
         <p:spPr>
           <a:xfrm>
-            <a:off x="2560320" y="3136392"/>
+            <a:off x="2560320" y="3145536"/>
             <a:ext cx="402336" cy="201168"/>
           </a:xfrm>
           <a:prstGeom prst="roundRect">
@@ -10449,7 +10449,7 @@
         </p:nvSpPr>
         <p:spPr>
           <a:xfrm>
-            <a:off x="2560320" y="3136392"/>
+            <a:off x="2560320" y="3145536"/>
             <a:ext cx="402336" cy="201168"/>
           </a:xfrm>
           <a:prstGeom prst="rect">
@@ -10488,7 +10488,7 @@
         </p:nvSpPr>
         <p:spPr>
           <a:xfrm>
-            <a:off x="694944" y="3374136"/>
+            <a:off x="694944" y="3383280"/>
             <a:ext cx="2267712" cy="228600"/>
           </a:xfrm>
           <a:prstGeom prst="rect">
@@ -10527,8 +10527,8 @@
         </p:nvSpPr>
         <p:spPr>
           <a:xfrm>
-            <a:off x="694944" y="3611880"/>
-            <a:ext cx="2267712" cy="329184"/>
+            <a:off x="694944" y="3602736"/>
+            <a:ext cx="2267712" cy="310896"/>
           </a:xfrm>
           <a:prstGeom prst="rect">
             <a:avLst/>
@@ -10566,7 +10566,7 @@
         </p:nvSpPr>
         <p:spPr>
           <a:xfrm>
-            <a:off x="713232" y="4032504"/>
+            <a:off x="713232" y="4023360"/>
             <a:ext cx="64008" cy="64008"/>
           </a:xfrm>
           <a:prstGeom prst="roundRect">
@@ -10588,7 +10588,7 @@
         </p:nvSpPr>
         <p:spPr>
           <a:xfrm>
-            <a:off x="841248" y="3977640"/>
+            <a:off x="841248" y="3968496"/>
             <a:ext cx="2121408" cy="292608"/>
           </a:xfrm>
           <a:prstGeom prst="rect">
@@ -10688,7 +10688,7 @@
         </p:nvSpPr>
         <p:spPr>
           <a:xfrm>
-            <a:off x="3291840" y="2990088"/>
+            <a:off x="3291840" y="2999232"/>
             <a:ext cx="2560320" cy="1645920"/>
           </a:xfrm>
           <a:prstGeom prst="roundRect">
@@ -10710,7 +10710,7 @@
         </p:nvSpPr>
         <p:spPr>
           <a:xfrm>
-            <a:off x="3438144" y="3172968"/>
+            <a:off x="3438144" y="3182112"/>
             <a:ext cx="128016" cy="128016"/>
           </a:xfrm>
           <a:prstGeom prst="roundRect">
@@ -10732,7 +10732,7 @@
         </p:nvSpPr>
         <p:spPr>
           <a:xfrm>
-            <a:off x="3639312" y="3118104"/>
+            <a:off x="3639312" y="3127248"/>
             <a:ext cx="1143000" cy="237744"/>
           </a:xfrm>
           <a:prstGeom prst="rect">
@@ -10785,7 +10785,7 @@
         </p:nvSpPr>
         <p:spPr>
           <a:xfrm>
-            <a:off x="4681728" y="3136392"/>
+            <a:off x="4681728" y="3145536"/>
             <a:ext cx="566928" cy="201168"/>
           </a:xfrm>
           <a:prstGeom prst="roundRect">
@@ -10807,7 +10807,7 @@
         </p:nvSpPr>
         <p:spPr>
           <a:xfrm>
-            <a:off x="4681728" y="3136392"/>
+            <a:off x="4681728" y="3145536"/>
             <a:ext cx="566928" cy="201168"/>
           </a:xfrm>
           <a:prstGeom prst="rect">
@@ -10846,7 +10846,7 @@
         </p:nvSpPr>
         <p:spPr>
           <a:xfrm>
-            <a:off x="5303520" y="3136392"/>
+            <a:off x="5303520" y="3145536"/>
             <a:ext cx="402336" cy="201168"/>
           </a:xfrm>
           <a:prstGeom prst="roundRect">
@@ -10868,7 +10868,7 @@
         </p:nvSpPr>
         <p:spPr>
           <a:xfrm>
-            <a:off x="5303520" y="3136392"/>
+            <a:off x="5303520" y="3145536"/>
             <a:ext cx="402336" cy="201168"/>
           </a:xfrm>
           <a:prstGeom prst="rect">
@@ -10907,7 +10907,7 @@
         </p:nvSpPr>
         <p:spPr>
           <a:xfrm>
-            <a:off x="3438144" y="3374136"/>
+            <a:off x="3438144" y="3383280"/>
             <a:ext cx="2267712" cy="228600"/>
           </a:xfrm>
           <a:prstGeom prst="rect">
@@ -10946,8 +10946,8 @@
         </p:nvSpPr>
         <p:spPr>
           <a:xfrm>
-            <a:off x="3438144" y="3611880"/>
-            <a:ext cx="2267712" cy="329184"/>
+            <a:off x="3438144" y="3602736"/>
+            <a:ext cx="2267712" cy="310896"/>
           </a:xfrm>
           <a:prstGeom prst="rect">
             <a:avLst/>
@@ -10985,7 +10985,7 @@
         </p:nvSpPr>
         <p:spPr>
           <a:xfrm>
-            <a:off x="3456432" y="4032504"/>
+            <a:off x="3456432" y="4023360"/>
             <a:ext cx="64008" cy="64008"/>
           </a:xfrm>
           <a:prstGeom prst="roundRect">
@@ -11007,7 +11007,7 @@
         </p:nvSpPr>
         <p:spPr>
           <a:xfrm>
-            <a:off x="3584448" y="3977640"/>
+            <a:off x="3584448" y="3968496"/>
             <a:ext cx="2121408" cy="292608"/>
           </a:xfrm>
           <a:prstGeom prst="rect">
@@ -11107,7 +11107,7 @@
         </p:nvSpPr>
         <p:spPr>
           <a:xfrm>
-            <a:off x="6035040" y="2990088"/>
+            <a:off x="6035040" y="2999232"/>
             <a:ext cx="2560320" cy="1645920"/>
           </a:xfrm>
           <a:prstGeom prst="roundRect">
@@ -11129,7 +11129,7 @@
         </p:nvSpPr>
         <p:spPr>
           <a:xfrm>
-            <a:off x="6181344" y="3172968"/>
+            <a:off x="6181344" y="3182112"/>
             <a:ext cx="128016" cy="128016"/>
           </a:xfrm>
           <a:prstGeom prst="roundRect">
@@ -11151,7 +11151,7 @@
         </p:nvSpPr>
         <p:spPr>
           <a:xfrm>
-            <a:off x="6382512" y="3118104"/>
+            <a:off x="6382512" y="3127248"/>
             <a:ext cx="1143000" cy="237744"/>
           </a:xfrm>
           <a:prstGeom prst="rect">
@@ -11204,7 +11204,7 @@
         </p:nvSpPr>
         <p:spPr>
           <a:xfrm>
-            <a:off x="7424928" y="3136392"/>
+            <a:off x="7424928" y="3145536"/>
             <a:ext cx="566928" cy="201168"/>
           </a:xfrm>
           <a:prstGeom prst="roundRect">
@@ -11226,7 +11226,7 @@
         </p:nvSpPr>
         <p:spPr>
           <a:xfrm>
-            <a:off x="7424928" y="3136392"/>
+            <a:off x="7424928" y="3145536"/>
             <a:ext cx="566928" cy="201168"/>
           </a:xfrm>
           <a:prstGeom prst="rect">
@@ -11265,7 +11265,7 @@
         </p:nvSpPr>
         <p:spPr>
           <a:xfrm>
-            <a:off x="8046720" y="3136392"/>
+            <a:off x="8046720" y="3145536"/>
             <a:ext cx="402336" cy="201168"/>
           </a:xfrm>
           <a:prstGeom prst="roundRect">
@@ -11287,7 +11287,7 @@
         </p:nvSpPr>
         <p:spPr>
           <a:xfrm>
-            <a:off x="8046720" y="3136392"/>
+            <a:off x="8046720" y="3145536"/>
             <a:ext cx="402336" cy="201168"/>
           </a:xfrm>
           <a:prstGeom prst="rect">
@@ -11326,7 +11326,7 @@
         </p:nvSpPr>
         <p:spPr>
           <a:xfrm>
-            <a:off x="6181344" y="3374136"/>
+            <a:off x="6181344" y="3383280"/>
             <a:ext cx="2267712" cy="228600"/>
           </a:xfrm>
           <a:prstGeom prst="rect">
@@ -11365,8 +11365,8 @@
         </p:nvSpPr>
         <p:spPr>
           <a:xfrm>
-            <a:off x="6181344" y="3611880"/>
-            <a:ext cx="2267712" cy="329184"/>
+            <a:off x="6181344" y="3602736"/>
+            <a:ext cx="2267712" cy="310896"/>
           </a:xfrm>
           <a:prstGeom prst="rect">
             <a:avLst/>
@@ -11404,7 +11404,7 @@
         </p:nvSpPr>
         <p:spPr>
           <a:xfrm>
-            <a:off x="6199632" y="4032504"/>
+            <a:off x="6199632" y="4023360"/>
             <a:ext cx="64008" cy="64008"/>
           </a:xfrm>
           <a:prstGeom prst="roundRect">
@@ -11426,7 +11426,7 @@
         </p:nvSpPr>
         <p:spPr>
           <a:xfrm>
-            <a:off x="6327648" y="3977640"/>
+            <a:off x="6327648" y="3968496"/>
             <a:ext cx="2121408" cy="292608"/>
           </a:xfrm>
           <a:prstGeom prst="rect">
@@ -11626,7 +11626,7 @@
                 <a:ea typeface="Calibri" pitchFamily="34" charset="-122"/>
                 <a:cs typeface="Calibri" pitchFamily="34" charset="-120"/>
               </a:rPr>
-              <a:t>Criterios de aceptación · HU07 a HU12</a:t>
+              <a:t>Criterios de aceptación (2/2)</a:t>
             </a:r>
             <a:endParaRPr lang="en-US" sz="3000" dirty="0"/>
           </a:p>
@@ -11640,7 +11640,7 @@
         </p:nvSpPr>
         <p:spPr>
           <a:xfrm>
-            <a:off x="548640" y="914400"/>
+            <a:off x="548640" y="987552"/>
             <a:ext cx="8046720" cy="228600"/>
           </a:xfrm>
           <a:prstGeom prst="rect">
@@ -11679,7 +11679,7 @@
         </p:nvSpPr>
         <p:spPr>
           <a:xfrm>
-            <a:off x="548640" y="1234440"/>
+            <a:off x="548640" y="1298448"/>
             <a:ext cx="2560320" cy="1645920"/>
           </a:xfrm>
           <a:prstGeom prst="roundRect">
@@ -11701,7 +11701,7 @@
         </p:nvSpPr>
         <p:spPr>
           <a:xfrm>
-            <a:off x="694944" y="1417320"/>
+            <a:off x="694944" y="1481328"/>
             <a:ext cx="128016" cy="128016"/>
           </a:xfrm>
           <a:prstGeom prst="roundRect">
@@ -11723,7 +11723,7 @@
         </p:nvSpPr>
         <p:spPr>
           <a:xfrm>
-            <a:off x="896112" y="1362456"/>
+            <a:off x="896112" y="1426464"/>
             <a:ext cx="1143000" cy="237744"/>
           </a:xfrm>
           <a:prstGeom prst="rect">
@@ -11776,7 +11776,7 @@
         </p:nvSpPr>
         <p:spPr>
           <a:xfrm>
-            <a:off x="1938528" y="1380744"/>
+            <a:off x="1938528" y="1444752"/>
             <a:ext cx="566928" cy="201168"/>
           </a:xfrm>
           <a:prstGeom prst="roundRect">
@@ -11798,7 +11798,7 @@
         </p:nvSpPr>
         <p:spPr>
           <a:xfrm>
-            <a:off x="1938528" y="1380744"/>
+            <a:off x="1938528" y="1444752"/>
             <a:ext cx="566928" cy="201168"/>
           </a:xfrm>
           <a:prstGeom prst="rect">
@@ -11837,7 +11837,7 @@
         </p:nvSpPr>
         <p:spPr>
           <a:xfrm>
-            <a:off x="2560320" y="1380744"/>
+            <a:off x="2560320" y="1444752"/>
             <a:ext cx="402336" cy="201168"/>
           </a:xfrm>
           <a:prstGeom prst="roundRect">
@@ -11859,7 +11859,7 @@
         </p:nvSpPr>
         <p:spPr>
           <a:xfrm>
-            <a:off x="2560320" y="1380744"/>
+            <a:off x="2560320" y="1444752"/>
             <a:ext cx="402336" cy="201168"/>
           </a:xfrm>
           <a:prstGeom prst="rect">
@@ -11898,7 +11898,7 @@
         </p:nvSpPr>
         <p:spPr>
           <a:xfrm>
-            <a:off x="694944" y="1618488"/>
+            <a:off x="694944" y="1682496"/>
             <a:ext cx="2267712" cy="228600"/>
           </a:xfrm>
           <a:prstGeom prst="rect">
@@ -11937,8 +11937,8 @@
         </p:nvSpPr>
         <p:spPr>
           <a:xfrm>
-            <a:off x="694944" y="1856232"/>
-            <a:ext cx="2267712" cy="329184"/>
+            <a:off x="694944" y="1901952"/>
+            <a:ext cx="2267712" cy="310896"/>
           </a:xfrm>
           <a:prstGeom prst="rect">
             <a:avLst/>
@@ -11976,7 +11976,7 @@
         </p:nvSpPr>
         <p:spPr>
           <a:xfrm>
-            <a:off x="713232" y="2276856"/>
+            <a:off x="713232" y="2322576"/>
             <a:ext cx="64008" cy="64008"/>
           </a:xfrm>
           <a:prstGeom prst="roundRect">
@@ -11998,7 +11998,7 @@
         </p:nvSpPr>
         <p:spPr>
           <a:xfrm>
-            <a:off x="841248" y="2221992"/>
+            <a:off x="841248" y="2267712"/>
             <a:ext cx="2121408" cy="292608"/>
           </a:xfrm>
           <a:prstGeom prst="rect">
@@ -12037,7 +12037,7 @@
         </p:nvSpPr>
         <p:spPr>
           <a:xfrm>
-            <a:off x="713232" y="2587752"/>
+            <a:off x="713232" y="2642616"/>
             <a:ext cx="64008" cy="64008"/>
           </a:xfrm>
           <a:prstGeom prst="roundRect">
@@ -12059,7 +12059,7 @@
         </p:nvSpPr>
         <p:spPr>
           <a:xfrm>
-            <a:off x="841248" y="2532888"/>
+            <a:off x="841248" y="2587752"/>
             <a:ext cx="2121408" cy="292608"/>
           </a:xfrm>
           <a:prstGeom prst="rect">
@@ -12098,7 +12098,7 @@
         </p:nvSpPr>
         <p:spPr>
           <a:xfrm>
-            <a:off x="3291840" y="1234440"/>
+            <a:off x="3291840" y="1298448"/>
             <a:ext cx="2560320" cy="1645920"/>
           </a:xfrm>
           <a:prstGeom prst="roundRect">
@@ -12120,7 +12120,7 @@
         </p:nvSpPr>
         <p:spPr>
           <a:xfrm>
-            <a:off x="3438144" y="1417320"/>
+            <a:off x="3438144" y="1481328"/>
             <a:ext cx="128016" cy="128016"/>
           </a:xfrm>
           <a:prstGeom prst="roundRect">
@@ -12142,7 +12142,7 @@
         </p:nvSpPr>
         <p:spPr>
           <a:xfrm>
-            <a:off x="3639312" y="1362456"/>
+            <a:off x="3639312" y="1426464"/>
             <a:ext cx="1143000" cy="237744"/>
           </a:xfrm>
           <a:prstGeom prst="rect">
@@ -12195,7 +12195,7 @@
         </p:nvSpPr>
         <p:spPr>
           <a:xfrm>
-            <a:off x="4681728" y="1380744"/>
+            <a:off x="4681728" y="1444752"/>
             <a:ext cx="566928" cy="201168"/>
           </a:xfrm>
           <a:prstGeom prst="roundRect">
@@ -12217,7 +12217,7 @@
         </p:nvSpPr>
         <p:spPr>
           <a:xfrm>
-            <a:off x="4681728" y="1380744"/>
+            <a:off x="4681728" y="1444752"/>
             <a:ext cx="566928" cy="201168"/>
           </a:xfrm>
           <a:prstGeom prst="rect">
@@ -12256,7 +12256,7 @@
         </p:nvSpPr>
         <p:spPr>
           <a:xfrm>
-            <a:off x="5303520" y="1380744"/>
+            <a:off x="5303520" y="1444752"/>
             <a:ext cx="402336" cy="201168"/>
           </a:xfrm>
           <a:prstGeom prst="roundRect">
@@ -12278,7 +12278,7 @@
         </p:nvSpPr>
         <p:spPr>
           <a:xfrm>
-            <a:off x="5303520" y="1380744"/>
+            <a:off x="5303520" y="1444752"/>
             <a:ext cx="402336" cy="201168"/>
           </a:xfrm>
           <a:prstGeom prst="rect">
@@ -12317,7 +12317,7 @@
         </p:nvSpPr>
         <p:spPr>
           <a:xfrm>
-            <a:off x="3438144" y="1618488"/>
+            <a:off x="3438144" y="1682496"/>
             <a:ext cx="2267712" cy="228600"/>
           </a:xfrm>
           <a:prstGeom prst="rect">
@@ -12356,8 +12356,8 @@
         </p:nvSpPr>
         <p:spPr>
           <a:xfrm>
-            <a:off x="3438144" y="1856232"/>
-            <a:ext cx="2267712" cy="329184"/>
+            <a:off x="3438144" y="1901952"/>
+            <a:ext cx="2267712" cy="310896"/>
           </a:xfrm>
           <a:prstGeom prst="rect">
             <a:avLst/>
@@ -12381,7 +12381,7 @@
                 <a:ea typeface="Calibri" pitchFamily="34" charset="-122"/>
                 <a:cs typeface="Calibri" pitchFamily="34" charset="-120"/>
               </a:rPr>
-              <a:t>Como investigador, quiero la etiqueta «seguro» o «inseguro», para obtener el resultado.</a:t>
+              <a:t>Como investigador, quiero la etiqueta seguro/inseguro, para obtener el resultado.</a:t>
             </a:r>
             <a:endParaRPr lang="en-US" sz="1000" dirty="0"/>
           </a:p>
@@ -12395,7 +12395,7 @@
         </p:nvSpPr>
         <p:spPr>
           <a:xfrm>
-            <a:off x="3456432" y="2276856"/>
+            <a:off x="3456432" y="2322576"/>
             <a:ext cx="64008" cy="64008"/>
           </a:xfrm>
           <a:prstGeom prst="roundRect">
@@ -12417,7 +12417,7 @@
         </p:nvSpPr>
         <p:spPr>
           <a:xfrm>
-            <a:off x="3584448" y="2221992"/>
+            <a:off x="3584448" y="2267712"/>
             <a:ext cx="2121408" cy="292608"/>
           </a:xfrm>
           <a:prstGeom prst="rect">
@@ -12456,7 +12456,7 @@
         </p:nvSpPr>
         <p:spPr>
           <a:xfrm>
-            <a:off x="3456432" y="2587752"/>
+            <a:off x="3456432" y="2642616"/>
             <a:ext cx="64008" cy="64008"/>
           </a:xfrm>
           <a:prstGeom prst="roundRect">
@@ -12478,7 +12478,7 @@
         </p:nvSpPr>
         <p:spPr>
           <a:xfrm>
-            <a:off x="3584448" y="2532888"/>
+            <a:off x="3584448" y="2587752"/>
             <a:ext cx="2121408" cy="292608"/>
           </a:xfrm>
           <a:prstGeom prst="rect">
@@ -12517,7 +12517,7 @@
         </p:nvSpPr>
         <p:spPr>
           <a:xfrm>
-            <a:off x="6035040" y="1234440"/>
+            <a:off x="6035040" y="1298448"/>
             <a:ext cx="2560320" cy="1645920"/>
           </a:xfrm>
           <a:prstGeom prst="roundRect">
@@ -12539,7 +12539,7 @@
         </p:nvSpPr>
         <p:spPr>
           <a:xfrm>
-            <a:off x="6181344" y="1417320"/>
+            <a:off x="6181344" y="1481328"/>
             <a:ext cx="128016" cy="128016"/>
           </a:xfrm>
           <a:prstGeom prst="roundRect">
@@ -12561,7 +12561,7 @@
         </p:nvSpPr>
         <p:spPr>
           <a:xfrm>
-            <a:off x="6382512" y="1362456"/>
+            <a:off x="6382512" y="1426464"/>
             <a:ext cx="1143000" cy="237744"/>
           </a:xfrm>
           <a:prstGeom prst="rect">
@@ -12614,7 +12614,7 @@
         </p:nvSpPr>
         <p:spPr>
           <a:xfrm>
-            <a:off x="7424928" y="1380744"/>
+            <a:off x="7424928" y="1444752"/>
             <a:ext cx="566928" cy="201168"/>
           </a:xfrm>
           <a:prstGeom prst="roundRect">
@@ -12636,7 +12636,7 @@
         </p:nvSpPr>
         <p:spPr>
           <a:xfrm>
-            <a:off x="7424928" y="1380744"/>
+            <a:off x="7424928" y="1444752"/>
             <a:ext cx="566928" cy="201168"/>
           </a:xfrm>
           <a:prstGeom prst="rect">
@@ -12675,7 +12675,7 @@
         </p:nvSpPr>
         <p:spPr>
           <a:xfrm>
-            <a:off x="8046720" y="1380744"/>
+            <a:off x="8046720" y="1444752"/>
             <a:ext cx="402336" cy="201168"/>
           </a:xfrm>
           <a:prstGeom prst="roundRect">
@@ -12697,7 +12697,7 @@
         </p:nvSpPr>
         <p:spPr>
           <a:xfrm>
-            <a:off x="8046720" y="1380744"/>
+            <a:off x="8046720" y="1444752"/>
             <a:ext cx="402336" cy="201168"/>
           </a:xfrm>
           <a:prstGeom prst="rect">
@@ -12736,7 +12736,7 @@
         </p:nvSpPr>
         <p:spPr>
           <a:xfrm>
-            <a:off x="6181344" y="1618488"/>
+            <a:off x="6181344" y="1682496"/>
             <a:ext cx="2267712" cy="228600"/>
           </a:xfrm>
           <a:prstGeom prst="rect">
@@ -12775,8 +12775,8 @@
         </p:nvSpPr>
         <p:spPr>
           <a:xfrm>
-            <a:off x="6181344" y="1856232"/>
-            <a:ext cx="2267712" cy="329184"/>
+            <a:off x="6181344" y="1901952"/>
+            <a:ext cx="2267712" cy="310896"/>
           </a:xfrm>
           <a:prstGeom prst="rect">
             <a:avLst/>
@@ -12814,7 +12814,7 @@
         </p:nvSpPr>
         <p:spPr>
           <a:xfrm>
-            <a:off x="6199632" y="2276856"/>
+            <a:off x="6199632" y="2322576"/>
             <a:ext cx="64008" cy="64008"/>
           </a:xfrm>
           <a:prstGeom prst="roundRect">
@@ -12836,7 +12836,7 @@
         </p:nvSpPr>
         <p:spPr>
           <a:xfrm>
-            <a:off x="6327648" y="2221992"/>
+            <a:off x="6327648" y="2267712"/>
             <a:ext cx="2121408" cy="292608"/>
           </a:xfrm>
           <a:prstGeom prst="rect">
@@ -12875,7 +12875,7 @@
         </p:nvSpPr>
         <p:spPr>
           <a:xfrm>
-            <a:off x="6199632" y="2587752"/>
+            <a:off x="6199632" y="2642616"/>
             <a:ext cx="64008" cy="64008"/>
           </a:xfrm>
           <a:prstGeom prst="roundRect">
@@ -12897,7 +12897,7 @@
         </p:nvSpPr>
         <p:spPr>
           <a:xfrm>
-            <a:off x="6327648" y="2532888"/>
+            <a:off x="6327648" y="2587752"/>
             <a:ext cx="2121408" cy="292608"/>
           </a:xfrm>
           <a:prstGeom prst="rect">
@@ -12936,7 +12936,7 @@
         </p:nvSpPr>
         <p:spPr>
           <a:xfrm>
-            <a:off x="548640" y="2990088"/>
+            <a:off x="548640" y="2999232"/>
             <a:ext cx="2560320" cy="1645920"/>
           </a:xfrm>
           <a:prstGeom prst="roundRect">
@@ -12958,7 +12958,7 @@
         </p:nvSpPr>
         <p:spPr>
           <a:xfrm>
-            <a:off x="694944" y="3172968"/>
+            <a:off x="694944" y="3182112"/>
             <a:ext cx="128016" cy="128016"/>
           </a:xfrm>
           <a:prstGeom prst="roundRect">
@@ -12980,7 +12980,7 @@
         </p:nvSpPr>
         <p:spPr>
           <a:xfrm>
-            <a:off x="896112" y="3118104"/>
+            <a:off x="896112" y="3127248"/>
             <a:ext cx="1143000" cy="237744"/>
           </a:xfrm>
           <a:prstGeom prst="rect">
@@ -13033,7 +13033,7 @@
         </p:nvSpPr>
         <p:spPr>
           <a:xfrm>
-            <a:off x="1938528" y="3136392"/>
+            <a:off x="1938528" y="3145536"/>
             <a:ext cx="566928" cy="201168"/>
           </a:xfrm>
           <a:prstGeom prst="roundRect">
@@ -13055,7 +13055,7 @@
         </p:nvSpPr>
         <p:spPr>
           <a:xfrm>
-            <a:off x="1938528" y="3136392"/>
+            <a:off x="1938528" y="3145536"/>
             <a:ext cx="566928" cy="201168"/>
           </a:xfrm>
           <a:prstGeom prst="rect">
@@ -13094,7 +13094,7 @@
         </p:nvSpPr>
         <p:spPr>
           <a:xfrm>
-            <a:off x="2560320" y="3136392"/>
+            <a:off x="2560320" y="3145536"/>
             <a:ext cx="402336" cy="201168"/>
           </a:xfrm>
           <a:prstGeom prst="roundRect">
@@ -13116,7 +13116,7 @@
         </p:nvSpPr>
         <p:spPr>
           <a:xfrm>
-            <a:off x="2560320" y="3136392"/>
+            <a:off x="2560320" y="3145536"/>
             <a:ext cx="402336" cy="201168"/>
           </a:xfrm>
           <a:prstGeom prst="rect">
@@ -13155,7 +13155,7 @@
         </p:nvSpPr>
         <p:spPr>
           <a:xfrm>
-            <a:off x="694944" y="3374136"/>
+            <a:off x="694944" y="3383280"/>
             <a:ext cx="2267712" cy="228600"/>
           </a:xfrm>
           <a:prstGeom prst="rect">
@@ -13194,8 +13194,8 @@
         </p:nvSpPr>
         <p:spPr>
           <a:xfrm>
-            <a:off x="694944" y="3611880"/>
-            <a:ext cx="2267712" cy="329184"/>
+            <a:off x="694944" y="3602736"/>
+            <a:ext cx="2267712" cy="310896"/>
           </a:xfrm>
           <a:prstGeom prst="rect">
             <a:avLst/>
@@ -13219,7 +13219,7 @@
                 <a:ea typeface="Calibri" pitchFamily="34" charset="-122"/>
                 <a:cs typeface="Calibri" pitchFamily="34" charset="-120"/>
               </a:rPr>
-              <a:t>Como evaluador, quiero una alerta ante una conducta insegura, para probar la respuesta.</a:t>
+              <a:t>Como evaluador, quiero una alerta ante un riesgo, para probar la respuesta.</a:t>
             </a:r>
             <a:endParaRPr lang="en-US" sz="1000" dirty="0"/>
           </a:p>
@@ -13233,7 +13233,7 @@
         </p:nvSpPr>
         <p:spPr>
           <a:xfrm>
-            <a:off x="713232" y="4032504"/>
+            <a:off x="713232" y="4023360"/>
             <a:ext cx="64008" cy="64008"/>
           </a:xfrm>
           <a:prstGeom prst="roundRect">
@@ -13255,7 +13255,7 @@
         </p:nvSpPr>
         <p:spPr>
           <a:xfrm>
-            <a:off x="841248" y="3977640"/>
+            <a:off x="841248" y="3968496"/>
             <a:ext cx="2121408" cy="292608"/>
           </a:xfrm>
           <a:prstGeom prst="rect">
@@ -13355,7 +13355,7 @@
         </p:nvSpPr>
         <p:spPr>
           <a:xfrm>
-            <a:off x="3291840" y="2990088"/>
+            <a:off x="3291840" y="2999232"/>
             <a:ext cx="2560320" cy="1645920"/>
           </a:xfrm>
           <a:prstGeom prst="roundRect">
@@ -13377,7 +13377,7 @@
         </p:nvSpPr>
         <p:spPr>
           <a:xfrm>
-            <a:off x="3438144" y="3172968"/>
+            <a:off x="3438144" y="3182112"/>
             <a:ext cx="128016" cy="128016"/>
           </a:xfrm>
           <a:prstGeom prst="roundRect">
@@ -13399,7 +13399,7 @@
         </p:nvSpPr>
         <p:spPr>
           <a:xfrm>
-            <a:off x="3639312" y="3118104"/>
+            <a:off x="3639312" y="3127248"/>
             <a:ext cx="1143000" cy="237744"/>
           </a:xfrm>
           <a:prstGeom prst="rect">
@@ -13452,7 +13452,7 @@
         </p:nvSpPr>
         <p:spPr>
           <a:xfrm>
-            <a:off x="4681728" y="3136392"/>
+            <a:off x="4681728" y="3145536"/>
             <a:ext cx="566928" cy="201168"/>
           </a:xfrm>
           <a:prstGeom prst="roundRect">
@@ -13474,7 +13474,7 @@
         </p:nvSpPr>
         <p:spPr>
           <a:xfrm>
-            <a:off x="4681728" y="3136392"/>
+            <a:off x="4681728" y="3145536"/>
             <a:ext cx="566928" cy="201168"/>
           </a:xfrm>
           <a:prstGeom prst="rect">
@@ -13513,7 +13513,7 @@
         </p:nvSpPr>
         <p:spPr>
           <a:xfrm>
-            <a:off x="5303520" y="3136392"/>
+            <a:off x="5303520" y="3145536"/>
             <a:ext cx="402336" cy="201168"/>
           </a:xfrm>
           <a:prstGeom prst="roundRect">
@@ -13535,7 +13535,7 @@
         </p:nvSpPr>
         <p:spPr>
           <a:xfrm>
-            <a:off x="5303520" y="3136392"/>
+            <a:off x="5303520" y="3145536"/>
             <a:ext cx="402336" cy="201168"/>
           </a:xfrm>
           <a:prstGeom prst="rect">
@@ -13574,7 +13574,7 @@
         </p:nvSpPr>
         <p:spPr>
           <a:xfrm>
-            <a:off x="3438144" y="3374136"/>
+            <a:off x="3438144" y="3383280"/>
             <a:ext cx="2267712" cy="228600"/>
           </a:xfrm>
           <a:prstGeom prst="rect">
@@ -13613,8 +13613,8 @@
         </p:nvSpPr>
         <p:spPr>
           <a:xfrm>
-            <a:off x="3438144" y="3611880"/>
-            <a:ext cx="2267712" cy="329184"/>
+            <a:off x="3438144" y="3602736"/>
+            <a:ext cx="2267712" cy="310896"/>
           </a:xfrm>
           <a:prstGeom prst="rect">
             <a:avLst/>
@@ -13652,7 +13652,7 @@
         </p:nvSpPr>
         <p:spPr>
           <a:xfrm>
-            <a:off x="3456432" y="4032504"/>
+            <a:off x="3456432" y="4023360"/>
             <a:ext cx="64008" cy="64008"/>
           </a:xfrm>
           <a:prstGeom prst="roundRect">
@@ -13674,7 +13674,7 @@
         </p:nvSpPr>
         <p:spPr>
           <a:xfrm>
-            <a:off x="3584448" y="3977640"/>
+            <a:off x="3584448" y="3968496"/>
             <a:ext cx="2121408" cy="292608"/>
           </a:xfrm>
           <a:prstGeom prst="rect">
@@ -13774,7 +13774,7 @@
         </p:nvSpPr>
         <p:spPr>
           <a:xfrm>
-            <a:off x="6035040" y="2990088"/>
+            <a:off x="6035040" y="2999232"/>
             <a:ext cx="2560320" cy="1645920"/>
           </a:xfrm>
           <a:prstGeom prst="roundRect">
@@ -13796,7 +13796,7 @@
         </p:nvSpPr>
         <p:spPr>
           <a:xfrm>
-            <a:off x="6181344" y="3172968"/>
+            <a:off x="6181344" y="3182112"/>
             <a:ext cx="128016" cy="128016"/>
           </a:xfrm>
           <a:prstGeom prst="roundRect">
@@ -13818,7 +13818,7 @@
         </p:nvSpPr>
         <p:spPr>
           <a:xfrm>
-            <a:off x="6382512" y="3118104"/>
+            <a:off x="6382512" y="3127248"/>
             <a:ext cx="1143000" cy="237744"/>
           </a:xfrm>
           <a:prstGeom prst="rect">
@@ -13871,7 +13871,7 @@
         </p:nvSpPr>
         <p:spPr>
           <a:xfrm>
-            <a:off x="7424928" y="3136392"/>
+            <a:off x="7424928" y="3145536"/>
             <a:ext cx="566928" cy="201168"/>
           </a:xfrm>
           <a:prstGeom prst="roundRect">
@@ -13893,7 +13893,7 @@
         </p:nvSpPr>
         <p:spPr>
           <a:xfrm>
-            <a:off x="7424928" y="3136392"/>
+            <a:off x="7424928" y="3145536"/>
             <a:ext cx="566928" cy="201168"/>
           </a:xfrm>
           <a:prstGeom prst="rect">
@@ -13932,7 +13932,7 @@
         </p:nvSpPr>
         <p:spPr>
           <a:xfrm>
-            <a:off x="8046720" y="3136392"/>
+            <a:off x="8046720" y="3145536"/>
             <a:ext cx="402336" cy="201168"/>
           </a:xfrm>
           <a:prstGeom prst="roundRect">
@@ -13954,7 +13954,7 @@
         </p:nvSpPr>
         <p:spPr>
           <a:xfrm>
-            <a:off x="8046720" y="3136392"/>
+            <a:off x="8046720" y="3145536"/>
             <a:ext cx="402336" cy="201168"/>
           </a:xfrm>
           <a:prstGeom prst="rect">
@@ -13993,7 +13993,7 @@
         </p:nvSpPr>
         <p:spPr>
           <a:xfrm>
-            <a:off x="6181344" y="3374136"/>
+            <a:off x="6181344" y="3383280"/>
             <a:ext cx="2267712" cy="228600"/>
           </a:xfrm>
           <a:prstGeom prst="rect">
@@ -14032,8 +14032,8 @@
         </p:nvSpPr>
         <p:spPr>
           <a:xfrm>
-            <a:off x="6181344" y="3611880"/>
-            <a:ext cx="2267712" cy="329184"/>
+            <a:off x="6181344" y="3602736"/>
+            <a:ext cx="2267712" cy="310896"/>
           </a:xfrm>
           <a:prstGeom prst="rect">
             <a:avLst/>
@@ -14071,7 +14071,7 @@
         </p:nvSpPr>
         <p:spPr>
           <a:xfrm>
-            <a:off x="6199632" y="4032504"/>
+            <a:off x="6199632" y="4023360"/>
             <a:ext cx="64008" cy="64008"/>
           </a:xfrm>
           <a:prstGeom prst="roundRect">
@@ -14093,7 +14093,7 @@
         </p:nvSpPr>
         <p:spPr>
           <a:xfrm>
-            <a:off x="6327648" y="3977640"/>
+            <a:off x="6327648" y="3968496"/>
             <a:ext cx="2121408" cy="292608"/>
           </a:xfrm>
           <a:prstGeom prst="rect">
@@ -14307,7 +14307,7 @@
         </p:nvSpPr>
         <p:spPr>
           <a:xfrm>
-            <a:off x="548640" y="914400"/>
+            <a:off x="548640" y="987552"/>
             <a:ext cx="8046720" cy="256032"/>
           </a:xfrm>
           <a:prstGeom prst="rect">
@@ -14332,7 +14332,7 @@
                 <a:ea typeface="Calibri" pitchFamily="34" charset="-122"/>
                 <a:cs typeface="Calibri" pitchFamily="34" charset="-120"/>
               </a:rPr>
-              <a:t>Sprint 1 · 19/10 – 01/11 · 3 historias · 7 puntos · estado al inicio del sprint</a:t>
+              <a:t>Sprint 1 · 19/10 – 01/11 · 3 historias · 7 puntos · inicio del sprint · tareas propuestas por el equipo</a:t>
             </a:r>
             <a:endParaRPr lang="en-US" sz="1200" dirty="0"/>
           </a:p>
@@ -14346,7 +14346,7 @@
         </p:nvSpPr>
         <p:spPr>
           <a:xfrm>
-            <a:off x="548640" y="1261872"/>
+            <a:off x="548640" y="1325880"/>
             <a:ext cx="1737360" cy="274320"/>
           </a:xfrm>
           <a:prstGeom prst="roundRect">
@@ -14368,7 +14368,7 @@
         </p:nvSpPr>
         <p:spPr>
           <a:xfrm>
-            <a:off x="548640" y="1261872"/>
+            <a:off x="548640" y="1325880"/>
             <a:ext cx="1737360" cy="274320"/>
           </a:xfrm>
           <a:prstGeom prst="rect">
@@ -14407,7 +14407,7 @@
         </p:nvSpPr>
         <p:spPr>
           <a:xfrm>
-            <a:off x="2414016" y="1261872"/>
+            <a:off x="2414016" y="1325880"/>
             <a:ext cx="1481328" cy="274320"/>
           </a:xfrm>
           <a:prstGeom prst="roundRect">
@@ -14429,7 +14429,7 @@
         </p:nvSpPr>
         <p:spPr>
           <a:xfrm>
-            <a:off x="2414016" y="1261872"/>
+            <a:off x="2414016" y="1325880"/>
             <a:ext cx="1481328" cy="274320"/>
           </a:xfrm>
           <a:prstGeom prst="rect">
@@ -14468,7 +14468,7 @@
         </p:nvSpPr>
         <p:spPr>
           <a:xfrm>
-            <a:off x="3968496" y="1261872"/>
+            <a:off x="3968496" y="1325880"/>
             <a:ext cx="1481328" cy="274320"/>
           </a:xfrm>
           <a:prstGeom prst="roundRect">
@@ -14490,7 +14490,7 @@
         </p:nvSpPr>
         <p:spPr>
           <a:xfrm>
-            <a:off x="3968496" y="1261872"/>
+            <a:off x="3968496" y="1325880"/>
             <a:ext cx="1481328" cy="274320"/>
           </a:xfrm>
           <a:prstGeom prst="rect">
@@ -14529,7 +14529,7 @@
         </p:nvSpPr>
         <p:spPr>
           <a:xfrm>
-            <a:off x="5522976" y="1261872"/>
+            <a:off x="5522976" y="1325880"/>
             <a:ext cx="1481328" cy="274320"/>
           </a:xfrm>
           <a:prstGeom prst="roundRect">
@@ -14551,7 +14551,7 @@
         </p:nvSpPr>
         <p:spPr>
           <a:xfrm>
-            <a:off x="5522976" y="1261872"/>
+            <a:off x="5522976" y="1325880"/>
             <a:ext cx="1481328" cy="274320"/>
           </a:xfrm>
           <a:prstGeom prst="rect">
@@ -14590,7 +14590,7 @@
         </p:nvSpPr>
         <p:spPr>
           <a:xfrm>
-            <a:off x="7077456" y="1261872"/>
+            <a:off x="7077456" y="1325880"/>
             <a:ext cx="1517904" cy="274320"/>
           </a:xfrm>
           <a:prstGeom prst="roundRect">
@@ -14612,7 +14612,7 @@
         </p:nvSpPr>
         <p:spPr>
           <a:xfrm>
-            <a:off x="7077456" y="1261872"/>
+            <a:off x="7077456" y="1325880"/>
             <a:ext cx="1517904" cy="274320"/>
           </a:xfrm>
           <a:prstGeom prst="rect">
@@ -14651,12 +14651,12 @@
         </p:nvSpPr>
         <p:spPr>
           <a:xfrm>
-            <a:off x="548640" y="1664208"/>
-            <a:ext cx="1737360" cy="914400"/>
+            <a:off x="548640" y="1719072"/>
+            <a:ext cx="1737360" cy="877824"/>
           </a:xfrm>
           <a:prstGeom prst="roundRect">
             <a:avLst>
-              <a:gd name="adj" fmla="val 10000"/>
+              <a:gd name="adj" fmla="val 10417"/>
             </a:avLst>
           </a:prstGeom>
           <a:solidFill>
@@ -14673,7 +14673,7 @@
         </p:nvSpPr>
         <p:spPr>
           <a:xfrm>
-            <a:off x="658368" y="1792224"/>
+            <a:off x="658368" y="1847088"/>
             <a:ext cx="128016" cy="128016"/>
           </a:xfrm>
           <a:prstGeom prst="roundRect">
@@ -14695,7 +14695,7 @@
         </p:nvSpPr>
         <p:spPr>
           <a:xfrm>
-            <a:off x="841248" y="1737360"/>
+            <a:off x="841248" y="1792224"/>
             <a:ext cx="1371600" cy="237744"/>
           </a:xfrm>
           <a:prstGeom prst="rect">
@@ -14748,7 +14748,7 @@
         </p:nvSpPr>
         <p:spPr>
           <a:xfrm>
-            <a:off x="658368" y="1993392"/>
+            <a:off x="658368" y="2048256"/>
             <a:ext cx="1554480" cy="237744"/>
           </a:xfrm>
           <a:prstGeom prst="rect">
@@ -14787,7 +14787,7 @@
         </p:nvSpPr>
         <p:spPr>
           <a:xfrm>
-            <a:off x="658368" y="2286000"/>
+            <a:off x="658368" y="2304288"/>
             <a:ext cx="566928" cy="201168"/>
           </a:xfrm>
           <a:prstGeom prst="roundRect">
@@ -14809,7 +14809,7 @@
         </p:nvSpPr>
         <p:spPr>
           <a:xfrm>
-            <a:off x="658368" y="2286000"/>
+            <a:off x="658368" y="2304288"/>
             <a:ext cx="566928" cy="201168"/>
           </a:xfrm>
           <a:prstGeom prst="rect">
@@ -14848,7 +14848,7 @@
         </p:nvSpPr>
         <p:spPr>
           <a:xfrm>
-            <a:off x="1280160" y="2286000"/>
+            <a:off x="1280160" y="2304288"/>
             <a:ext cx="402336" cy="201168"/>
           </a:xfrm>
           <a:prstGeom prst="roundRect">
@@ -14870,7 +14870,7 @@
         </p:nvSpPr>
         <p:spPr>
           <a:xfrm>
-            <a:off x="1280160" y="2286000"/>
+            <a:off x="1280160" y="2304288"/>
             <a:ext cx="402336" cy="201168"/>
           </a:xfrm>
           <a:prstGeom prst="rect">
@@ -14909,12 +14909,12 @@
         </p:nvSpPr>
         <p:spPr>
           <a:xfrm>
-            <a:off x="2414016" y="1664208"/>
-            <a:ext cx="1481328" cy="914400"/>
+            <a:off x="2414016" y="1719072"/>
+            <a:ext cx="1481328" cy="877824"/>
           </a:xfrm>
           <a:prstGeom prst="roundRect">
             <a:avLst>
-              <a:gd name="adj" fmla="val 10000"/>
+              <a:gd name="adj" fmla="val 10417"/>
             </a:avLst>
           </a:prstGeom>
           <a:solidFill>
@@ -14931,12 +14931,12 @@
         </p:nvSpPr>
         <p:spPr>
           <a:xfrm>
-            <a:off x="3968496" y="1664208"/>
-            <a:ext cx="1481328" cy="914400"/>
+            <a:off x="3968496" y="1719072"/>
+            <a:ext cx="1481328" cy="877824"/>
           </a:xfrm>
           <a:prstGeom prst="roundRect">
             <a:avLst>
-              <a:gd name="adj" fmla="val 10000"/>
+              <a:gd name="adj" fmla="val 10417"/>
             </a:avLst>
           </a:prstGeom>
           <a:solidFill>
@@ -14953,12 +14953,12 @@
         </p:nvSpPr>
         <p:spPr>
           <a:xfrm>
-            <a:off x="5522976" y="1664208"/>
-            <a:ext cx="1481328" cy="914400"/>
+            <a:off x="5522976" y="1719072"/>
+            <a:ext cx="1481328" cy="877824"/>
           </a:xfrm>
           <a:prstGeom prst="roundRect">
             <a:avLst>
-              <a:gd name="adj" fmla="val 10000"/>
+              <a:gd name="adj" fmla="val 10417"/>
             </a:avLst>
           </a:prstGeom>
           <a:solidFill>
@@ -14975,12 +14975,12 @@
         </p:nvSpPr>
         <p:spPr>
           <a:xfrm>
-            <a:off x="7077456" y="1664208"/>
-            <a:ext cx="1517904" cy="914400"/>
+            <a:off x="7077456" y="1719072"/>
+            <a:ext cx="1517904" cy="877824"/>
           </a:xfrm>
           <a:prstGeom prst="roundRect">
             <a:avLst>
-              <a:gd name="adj" fmla="val 10000"/>
+              <a:gd name="adj" fmla="val 10417"/>
             </a:avLst>
           </a:prstGeom>
           <a:solidFill>
@@ -14997,12 +14997,12 @@
         </p:nvSpPr>
         <p:spPr>
           <a:xfrm>
-            <a:off x="2487168" y="1728216"/>
-            <a:ext cx="1335024" cy="237744"/>
+            <a:off x="2487168" y="1783080"/>
+            <a:ext cx="1335024" cy="228600"/>
           </a:xfrm>
           <a:prstGeom prst="roundRect">
             <a:avLst>
-              <a:gd name="adj" fmla="val 15385"/>
+              <a:gd name="adj" fmla="val 16000"/>
             </a:avLst>
           </a:prstGeom>
           <a:solidFill>
@@ -15019,8 +15019,8 @@
         </p:nvSpPr>
         <p:spPr>
           <a:xfrm>
-            <a:off x="2560320" y="1728216"/>
-            <a:ext cx="1207008" cy="237744"/>
+            <a:off x="2560320" y="1783080"/>
+            <a:ext cx="1207008" cy="228600"/>
           </a:xfrm>
           <a:prstGeom prst="rect">
             <a:avLst/>
@@ -15058,12 +15058,12 @@
         </p:nvSpPr>
         <p:spPr>
           <a:xfrm>
-            <a:off x="2487168" y="2002536"/>
-            <a:ext cx="1335024" cy="237744"/>
+            <a:off x="2487168" y="2039112"/>
+            <a:ext cx="1335024" cy="228600"/>
           </a:xfrm>
           <a:prstGeom prst="roundRect">
             <a:avLst>
-              <a:gd name="adj" fmla="val 15385"/>
+              <a:gd name="adj" fmla="val 16000"/>
             </a:avLst>
           </a:prstGeom>
           <a:solidFill>
@@ -15080,8 +15080,8 @@
         </p:nvSpPr>
         <p:spPr>
           <a:xfrm>
-            <a:off x="2560320" y="2002536"/>
-            <a:ext cx="1207008" cy="237744"/>
+            <a:off x="2560320" y="2039112"/>
+            <a:ext cx="1207008" cy="228600"/>
           </a:xfrm>
           <a:prstGeom prst="rect">
             <a:avLst/>
@@ -15119,12 +15119,12 @@
         </p:nvSpPr>
         <p:spPr>
           <a:xfrm>
-            <a:off x="2487168" y="2276856"/>
-            <a:ext cx="1335024" cy="237744"/>
+            <a:off x="2487168" y="2295144"/>
+            <a:ext cx="1335024" cy="228600"/>
           </a:xfrm>
           <a:prstGeom prst="roundRect">
             <a:avLst>
-              <a:gd name="adj" fmla="val 15385"/>
+              <a:gd name="adj" fmla="val 16000"/>
             </a:avLst>
           </a:prstGeom>
           <a:solidFill>
@@ -15141,8 +15141,8 @@
         </p:nvSpPr>
         <p:spPr>
           <a:xfrm>
-            <a:off x="2560320" y="2276856"/>
-            <a:ext cx="1207008" cy="237744"/>
+            <a:off x="2560320" y="2295144"/>
+            <a:ext cx="1207008" cy="228600"/>
           </a:xfrm>
           <a:prstGeom prst="rect">
             <a:avLst/>
@@ -15180,12 +15180,12 @@
         </p:nvSpPr>
         <p:spPr>
           <a:xfrm>
-            <a:off x="548640" y="2670048"/>
-            <a:ext cx="1737360" cy="914400"/>
+            <a:off x="548640" y="2688336"/>
+            <a:ext cx="1737360" cy="877824"/>
           </a:xfrm>
           <a:prstGeom prst="roundRect">
             <a:avLst>
-              <a:gd name="adj" fmla="val 10000"/>
+              <a:gd name="adj" fmla="val 10417"/>
             </a:avLst>
           </a:prstGeom>
           <a:solidFill>
@@ -15202,7 +15202,7 @@
         </p:nvSpPr>
         <p:spPr>
           <a:xfrm>
-            <a:off x="658368" y="2798064"/>
+            <a:off x="658368" y="2816352"/>
             <a:ext cx="128016" cy="128016"/>
           </a:xfrm>
           <a:prstGeom prst="roundRect">
@@ -15224,7 +15224,7 @@
         </p:nvSpPr>
         <p:spPr>
           <a:xfrm>
-            <a:off x="841248" y="2743200"/>
+            <a:off x="841248" y="2761488"/>
             <a:ext cx="1371600" cy="237744"/>
           </a:xfrm>
           <a:prstGeom prst="rect">
@@ -15277,7 +15277,7 @@
         </p:nvSpPr>
         <p:spPr>
           <a:xfrm>
-            <a:off x="658368" y="2999232"/>
+            <a:off x="658368" y="3017520"/>
             <a:ext cx="1554480" cy="237744"/>
           </a:xfrm>
           <a:prstGeom prst="rect">
@@ -15316,7 +15316,7 @@
         </p:nvSpPr>
         <p:spPr>
           <a:xfrm>
-            <a:off x="658368" y="3291840"/>
+            <a:off x="658368" y="3273552"/>
             <a:ext cx="566928" cy="201168"/>
           </a:xfrm>
           <a:prstGeom prst="roundRect">
@@ -15338,7 +15338,7 @@
         </p:nvSpPr>
         <p:spPr>
           <a:xfrm>
-            <a:off x="658368" y="3291840"/>
+            <a:off x="658368" y="3273552"/>
             <a:ext cx="566928" cy="201168"/>
           </a:xfrm>
           <a:prstGeom prst="rect">
@@ -15377,7 +15377,7 @@
         </p:nvSpPr>
         <p:spPr>
           <a:xfrm>
-            <a:off x="1280160" y="3291840"/>
+            <a:off x="1280160" y="3273552"/>
             <a:ext cx="402336" cy="201168"/>
           </a:xfrm>
           <a:prstGeom prst="roundRect">
@@ -15399,7 +15399,7 @@
         </p:nvSpPr>
         <p:spPr>
           <a:xfrm>
-            <a:off x="1280160" y="3291840"/>
+            <a:off x="1280160" y="3273552"/>
             <a:ext cx="402336" cy="201168"/>
           </a:xfrm>
           <a:prstGeom prst="rect">
@@ -15438,12 +15438,12 @@
         </p:nvSpPr>
         <p:spPr>
           <a:xfrm>
-            <a:off x="2414016" y="2670048"/>
-            <a:ext cx="1481328" cy="914400"/>
+            <a:off x="2414016" y="2688336"/>
+            <a:ext cx="1481328" cy="877824"/>
           </a:xfrm>
           <a:prstGeom prst="roundRect">
             <a:avLst>
-              <a:gd name="adj" fmla="val 10000"/>
+              <a:gd name="adj" fmla="val 10417"/>
             </a:avLst>
           </a:prstGeom>
           <a:solidFill>
@@ -15460,12 +15460,12 @@
         </p:nvSpPr>
         <p:spPr>
           <a:xfrm>
-            <a:off x="3968496" y="2670048"/>
-            <a:ext cx="1481328" cy="914400"/>
+            <a:off x="3968496" y="2688336"/>
+            <a:ext cx="1481328" cy="877824"/>
           </a:xfrm>
           <a:prstGeom prst="roundRect">
             <a:avLst>
-              <a:gd name="adj" fmla="val 10000"/>
+              <a:gd name="adj" fmla="val 10417"/>
             </a:avLst>
           </a:prstGeom>
           <a:solidFill>
@@ -15482,12 +15482,12 @@
         </p:nvSpPr>
         <p:spPr>
           <a:xfrm>
-            <a:off x="5522976" y="2670048"/>
-            <a:ext cx="1481328" cy="914400"/>
+            <a:off x="5522976" y="2688336"/>
+            <a:ext cx="1481328" cy="877824"/>
           </a:xfrm>
           <a:prstGeom prst="roundRect">
             <a:avLst>
-              <a:gd name="adj" fmla="val 10000"/>
+              <a:gd name="adj" fmla="val 10417"/>
             </a:avLst>
           </a:prstGeom>
           <a:solidFill>
@@ -15504,12 +15504,12 @@
         </p:nvSpPr>
         <p:spPr>
           <a:xfrm>
-            <a:off x="7077456" y="2670048"/>
-            <a:ext cx="1517904" cy="914400"/>
+            <a:off x="7077456" y="2688336"/>
+            <a:ext cx="1517904" cy="877824"/>
           </a:xfrm>
           <a:prstGeom prst="roundRect">
             <a:avLst>
-              <a:gd name="adj" fmla="val 10000"/>
+              <a:gd name="adj" fmla="val 10417"/>
             </a:avLst>
           </a:prstGeom>
           <a:solidFill>
@@ -15526,12 +15526,12 @@
         </p:nvSpPr>
         <p:spPr>
           <a:xfrm>
-            <a:off x="2487168" y="2734056"/>
-            <a:ext cx="1335024" cy="237744"/>
+            <a:off x="2487168" y="2752344"/>
+            <a:ext cx="1335024" cy="228600"/>
           </a:xfrm>
           <a:prstGeom prst="roundRect">
             <a:avLst>
-              <a:gd name="adj" fmla="val 15385"/>
+              <a:gd name="adj" fmla="val 16000"/>
             </a:avLst>
           </a:prstGeom>
           <a:solidFill>
@@ -15548,8 +15548,8 @@
         </p:nvSpPr>
         <p:spPr>
           <a:xfrm>
-            <a:off x="2560320" y="2734056"/>
-            <a:ext cx="1207008" cy="237744"/>
+            <a:off x="2560320" y="2752344"/>
+            <a:ext cx="1207008" cy="228600"/>
           </a:xfrm>
           <a:prstGeom prst="rect">
             <a:avLst/>
@@ -15588,11 +15588,11 @@
         <p:spPr>
           <a:xfrm>
             <a:off x="2487168" y="3008376"/>
-            <a:ext cx="1335024" cy="237744"/>
+            <a:ext cx="1335024" cy="228600"/>
           </a:xfrm>
           <a:prstGeom prst="roundRect">
             <a:avLst>
-              <a:gd name="adj" fmla="val 15385"/>
+              <a:gd name="adj" fmla="val 16000"/>
             </a:avLst>
           </a:prstGeom>
           <a:solidFill>
@@ -15610,7 +15610,7 @@
         <p:spPr>
           <a:xfrm>
             <a:off x="2560320" y="3008376"/>
-            <a:ext cx="1207008" cy="237744"/>
+            <a:ext cx="1207008" cy="228600"/>
           </a:xfrm>
           <a:prstGeom prst="rect">
             <a:avLst/>
@@ -15648,12 +15648,12 @@
         </p:nvSpPr>
         <p:spPr>
           <a:xfrm>
-            <a:off x="2487168" y="3282696"/>
-            <a:ext cx="1335024" cy="237744"/>
+            <a:off x="2487168" y="3264408"/>
+            <a:ext cx="1335024" cy="228600"/>
           </a:xfrm>
           <a:prstGeom prst="roundRect">
             <a:avLst>
-              <a:gd name="adj" fmla="val 15385"/>
+              <a:gd name="adj" fmla="val 16000"/>
             </a:avLst>
           </a:prstGeom>
           <a:solidFill>
@@ -15670,8 +15670,8 @@
         </p:nvSpPr>
         <p:spPr>
           <a:xfrm>
-            <a:off x="2560320" y="3282696"/>
-            <a:ext cx="1207008" cy="237744"/>
+            <a:off x="2560320" y="3264408"/>
+            <a:ext cx="1207008" cy="228600"/>
           </a:xfrm>
           <a:prstGeom prst="rect">
             <a:avLst/>
@@ -15709,12 +15709,12 @@
         </p:nvSpPr>
         <p:spPr>
           <a:xfrm>
-            <a:off x="548640" y="3675888"/>
-            <a:ext cx="1737360" cy="914400"/>
+            <a:off x="548640" y="3657600"/>
+            <a:ext cx="1737360" cy="877824"/>
           </a:xfrm>
           <a:prstGeom prst="roundRect">
             <a:avLst>
-              <a:gd name="adj" fmla="val 10000"/>
+              <a:gd name="adj" fmla="val 10417"/>
             </a:avLst>
           </a:prstGeom>
           <a:solidFill>
@@ -15731,7 +15731,7 @@
         </p:nvSpPr>
         <p:spPr>
           <a:xfrm>
-            <a:off x="658368" y="3803904"/>
+            <a:off x="658368" y="3785616"/>
             <a:ext cx="128016" cy="128016"/>
           </a:xfrm>
           <a:prstGeom prst="roundRect">
@@ -15753,7 +15753,7 @@
         </p:nvSpPr>
         <p:spPr>
           <a:xfrm>
-            <a:off x="841248" y="3749040"/>
+            <a:off x="841248" y="3730752"/>
             <a:ext cx="1371600" cy="237744"/>
           </a:xfrm>
           <a:prstGeom prst="rect">
@@ -15806,7 +15806,7 @@
         </p:nvSpPr>
         <p:spPr>
           <a:xfrm>
-            <a:off x="658368" y="4005072"/>
+            <a:off x="658368" y="3986784"/>
             <a:ext cx="1554480" cy="237744"/>
           </a:xfrm>
           <a:prstGeom prst="rect">
@@ -15845,7 +15845,7 @@
         </p:nvSpPr>
         <p:spPr>
           <a:xfrm>
-            <a:off x="658368" y="4297680"/>
+            <a:off x="658368" y="4242816"/>
             <a:ext cx="566928" cy="201168"/>
           </a:xfrm>
           <a:prstGeom prst="roundRect">
@@ -15867,7 +15867,7 @@
         </p:nvSpPr>
         <p:spPr>
           <a:xfrm>
-            <a:off x="658368" y="4297680"/>
+            <a:off x="658368" y="4242816"/>
             <a:ext cx="566928" cy="201168"/>
           </a:xfrm>
           <a:prstGeom prst="rect">
@@ -15906,7 +15906,7 @@
         </p:nvSpPr>
         <p:spPr>
           <a:xfrm>
-            <a:off x="1280160" y="4297680"/>
+            <a:off x="1280160" y="4242816"/>
             <a:ext cx="402336" cy="201168"/>
           </a:xfrm>
           <a:prstGeom prst="roundRect">
@@ -15928,7 +15928,7 @@
         </p:nvSpPr>
         <p:spPr>
           <a:xfrm>
-            <a:off x="1280160" y="4297680"/>
+            <a:off x="1280160" y="4242816"/>
             <a:ext cx="402336" cy="201168"/>
           </a:xfrm>
           <a:prstGeom prst="rect">
@@ -15967,12 +15967,12 @@
         </p:nvSpPr>
         <p:spPr>
           <a:xfrm>
-            <a:off x="2414016" y="3675888"/>
-            <a:ext cx="1481328" cy="914400"/>
+            <a:off x="2414016" y="3657600"/>
+            <a:ext cx="1481328" cy="877824"/>
           </a:xfrm>
           <a:prstGeom prst="roundRect">
             <a:avLst>
-              <a:gd name="adj" fmla="val 10000"/>
+              <a:gd name="adj" fmla="val 10417"/>
             </a:avLst>
           </a:prstGeom>
           <a:solidFill>
@@ -15989,12 +15989,12 @@
         </p:nvSpPr>
         <p:spPr>
           <a:xfrm>
-            <a:off x="3968496" y="3675888"/>
-            <a:ext cx="1481328" cy="914400"/>
+            <a:off x="3968496" y="3657600"/>
+            <a:ext cx="1481328" cy="877824"/>
           </a:xfrm>
           <a:prstGeom prst="roundRect">
             <a:avLst>
-              <a:gd name="adj" fmla="val 10000"/>
+              <a:gd name="adj" fmla="val 10417"/>
             </a:avLst>
           </a:prstGeom>
           <a:solidFill>
@@ -16011,12 +16011,12 @@
         </p:nvSpPr>
         <p:spPr>
           <a:xfrm>
-            <a:off x="5522976" y="3675888"/>
-            <a:ext cx="1481328" cy="914400"/>
+            <a:off x="5522976" y="3657600"/>
+            <a:ext cx="1481328" cy="877824"/>
           </a:xfrm>
           <a:prstGeom prst="roundRect">
             <a:avLst>
-              <a:gd name="adj" fmla="val 10000"/>
+              <a:gd name="adj" fmla="val 10417"/>
             </a:avLst>
           </a:prstGeom>
           <a:solidFill>
@@ -16033,12 +16033,12 @@
         </p:nvSpPr>
         <p:spPr>
           <a:xfrm>
-            <a:off x="7077456" y="3675888"/>
-            <a:ext cx="1517904" cy="914400"/>
+            <a:off x="7077456" y="3657600"/>
+            <a:ext cx="1517904" cy="877824"/>
           </a:xfrm>
           <a:prstGeom prst="roundRect">
             <a:avLst>
-              <a:gd name="adj" fmla="val 10000"/>
+              <a:gd name="adj" fmla="val 10417"/>
             </a:avLst>
           </a:prstGeom>
           <a:solidFill>
@@ -16055,12 +16055,12 @@
         </p:nvSpPr>
         <p:spPr>
           <a:xfrm>
-            <a:off x="2487168" y="3739896"/>
-            <a:ext cx="1335024" cy="237744"/>
+            <a:off x="2487168" y="3721608"/>
+            <a:ext cx="1335024" cy="228600"/>
           </a:xfrm>
           <a:prstGeom prst="roundRect">
             <a:avLst>
-              <a:gd name="adj" fmla="val 15385"/>
+              <a:gd name="adj" fmla="val 16000"/>
             </a:avLst>
           </a:prstGeom>
           <a:solidFill>
@@ -16077,8 +16077,8 @@
         </p:nvSpPr>
         <p:spPr>
           <a:xfrm>
-            <a:off x="2560320" y="3739896"/>
-            <a:ext cx="1207008" cy="237744"/>
+            <a:off x="2560320" y="3721608"/>
+            <a:ext cx="1207008" cy="228600"/>
           </a:xfrm>
           <a:prstGeom prst="rect">
             <a:avLst/>
@@ -16116,12 +16116,12 @@
         </p:nvSpPr>
         <p:spPr>
           <a:xfrm>
-            <a:off x="2487168" y="4014216"/>
-            <a:ext cx="1335024" cy="237744"/>
+            <a:off x="2487168" y="3977640"/>
+            <a:ext cx="1335024" cy="228600"/>
           </a:xfrm>
           <a:prstGeom prst="roundRect">
             <a:avLst>
-              <a:gd name="adj" fmla="val 15385"/>
+              <a:gd name="adj" fmla="val 16000"/>
             </a:avLst>
           </a:prstGeom>
           <a:solidFill>
@@ -16138,8 +16138,8 @@
         </p:nvSpPr>
         <p:spPr>
           <a:xfrm>
-            <a:off x="2560320" y="4014216"/>
-            <a:ext cx="1207008" cy="237744"/>
+            <a:off x="2560320" y="3977640"/>
+            <a:ext cx="1207008" cy="228600"/>
           </a:xfrm>
           <a:prstGeom prst="rect">
             <a:avLst/>
@@ -16177,12 +16177,12 @@
         </p:nvSpPr>
         <p:spPr>
           <a:xfrm>
-            <a:off x="2487168" y="4288536"/>
-            <a:ext cx="1335024" cy="237744"/>
+            <a:off x="2487168" y="4233672"/>
+            <a:ext cx="1335024" cy="228600"/>
           </a:xfrm>
           <a:prstGeom prst="roundRect">
             <a:avLst>
-              <a:gd name="adj" fmla="val 15385"/>
+              <a:gd name="adj" fmla="val 16000"/>
             </a:avLst>
           </a:prstGeom>
           <a:solidFill>
@@ -16199,8 +16199,8 @@
         </p:nvSpPr>
         <p:spPr>
           <a:xfrm>
-            <a:off x="2560320" y="4288536"/>
-            <a:ext cx="1207008" cy="237744"/>
+            <a:off x="2560320" y="4233672"/>
+            <a:ext cx="1207008" cy="228600"/>
           </a:xfrm>
           <a:prstGeom prst="rect">
             <a:avLst/>
@@ -16227,45 +16227,6 @@
               <a:t>Probar con 1 video</a:t>
             </a:r>
             <a:endParaRPr lang="en-US" sz="1000" dirty="0"/>
-          </a:p>
-        </p:txBody>
-      </p:sp>
-      <p:sp>
-        <p:nvSpPr>
-          <p:cNvPr id="68" name="obj255"/>
-          <p:cNvSpPr txBox="1"/>
-          <p:nvPr/>
-        </p:nvSpPr>
-        <p:spPr>
-          <a:xfrm>
-            <a:off x="548640" y="4572000"/>
-            <a:ext cx="8046720" cy="182880"/>
-          </a:xfrm>
-          <a:prstGeom prst="rect">
-            <a:avLst/>
-          </a:prstGeom>
-          <a:noFill/>
-          <a:ln/>
-        </p:spPr>
-        <p:txBody>
-          <a:bodyPr wrap="square" lIns="0" tIns="0" rIns="0" bIns="0" rtlCol="0" anchor="t"/>
-          <a:lstStyle/>
-          <a:p>
-            <a:pPr algn="l" indent="0" marL="0">
-              <a:buNone/>
-            </a:pPr>
-            <a:r>
-              <a:rPr lang="en-US" sz="900" dirty="0">
-                <a:solidFill>
-                  <a:srgbClr val="6B7280"/>
-                </a:solidFill>
-                <a:latin typeface="Calibri" pitchFamily="34" charset="0"/>
-                <a:ea typeface="Calibri" pitchFamily="34" charset="-122"/>
-                <a:cs typeface="Calibri" pitchFamily="34" charset="-120"/>
-              </a:rPr>
-              <a:t>Tareas = propuesta del equipo · las notas amarillas se mueven de columna en el Daily Standup</a:t>
-            </a:r>
-            <a:endParaRPr lang="en-US" sz="900" dirty="0"/>
           </a:p>
         </p:txBody>
       </p:sp>
@@ -16385,18 +16346,18 @@
       </p:sp>
       <p:sp>
         <p:nvSpPr>
-          <p:cNvPr id="3" name="obj256"/>
+          <p:cNvPr id="3" name="obj255"/>
           <p:cNvSpPr/>
           <p:nvPr/>
         </p:nvSpPr>
         <p:spPr>
           <a:xfrm>
             <a:off x="548640" y="1097280"/>
-            <a:ext cx="3931920" cy="3429000"/>
+            <a:ext cx="3931920" cy="3337560"/>
           </a:xfrm>
           <a:prstGeom prst="roundRect">
             <a:avLst>
-              <a:gd name="adj" fmla="val 3733"/>
+              <a:gd name="adj" fmla="val 3836"/>
             </a:avLst>
           </a:prstGeom>
           <a:solidFill>
@@ -16407,7 +16368,7 @@
       </p:sp>
       <p:sp>
         <p:nvSpPr>
-          <p:cNvPr id="4" name="obj257"/>
+          <p:cNvPr id="4" name="obj256"/>
           <p:cNvSpPr txBox="1"/>
           <p:nvPr/>
         </p:nvSpPr>
@@ -16446,7 +16407,7 @@
       </p:sp>
       <p:sp>
         <p:nvSpPr>
-          <p:cNvPr id="5" name="obj258"/>
+          <p:cNvPr id="5" name="obj257"/>
           <p:cNvSpPr txBox="1"/>
           <p:nvPr/>
         </p:nvSpPr>
@@ -16485,7 +16446,7 @@
       </p:sp>
       <p:sp>
         <p:nvSpPr>
-          <p:cNvPr id="6" name="obj259"/>
+          <p:cNvPr id="6" name="obj258"/>
           <p:cNvSpPr txBox="1"/>
           <p:nvPr/>
         </p:nvSpPr>
@@ -16524,7 +16485,7 @@
       </p:sp>
       <p:sp>
         <p:nvSpPr>
-          <p:cNvPr id="7" name="obj260"/>
+          <p:cNvPr id="7" name="obj259"/>
           <p:cNvSpPr/>
           <p:nvPr/>
         </p:nvSpPr>
@@ -16546,7 +16507,7 @@
       </p:sp>
       <p:sp>
         <p:nvSpPr>
-          <p:cNvPr id="8" name="obj261"/>
+          <p:cNvPr id="8" name="obj260"/>
           <p:cNvSpPr txBox="1"/>
           <p:nvPr/>
         </p:nvSpPr>
@@ -16585,7 +16546,7 @@
       </p:sp>
       <p:sp>
         <p:nvSpPr>
-          <p:cNvPr id="9" name="obj262"/>
+          <p:cNvPr id="9" name="obj261"/>
           <p:cNvSpPr txBox="1"/>
           <p:nvPr/>
         </p:nvSpPr>
@@ -16624,7 +16585,7 @@
       </p:sp>
       <p:sp>
         <p:nvSpPr>
-          <p:cNvPr id="10" name="obj263"/>
+          <p:cNvPr id="10" name="obj262"/>
           <p:cNvSpPr txBox="1"/>
           <p:nvPr/>
         </p:nvSpPr>
@@ -16663,7 +16624,7 @@
       </p:sp>
       <p:sp>
         <p:nvSpPr>
-          <p:cNvPr id="11" name="obj264"/>
+          <p:cNvPr id="11" name="obj263"/>
           <p:cNvSpPr/>
           <p:nvPr/>
         </p:nvSpPr>
@@ -16685,7 +16646,7 @@
       </p:sp>
       <p:sp>
         <p:nvSpPr>
-          <p:cNvPr id="12" name="obj265"/>
+          <p:cNvPr id="12" name="obj264"/>
           <p:cNvSpPr txBox="1"/>
           <p:nvPr/>
         </p:nvSpPr>
@@ -16724,7 +16685,7 @@
       </p:sp>
       <p:sp>
         <p:nvSpPr>
-          <p:cNvPr id="13" name="obj266"/>
+          <p:cNvPr id="13" name="obj265"/>
           <p:cNvSpPr txBox="1"/>
           <p:nvPr/>
         </p:nvSpPr>
@@ -16763,7 +16724,7 @@
       </p:sp>
       <p:sp>
         <p:nvSpPr>
-          <p:cNvPr id="14" name="obj267"/>
+          <p:cNvPr id="14" name="obj266"/>
           <p:cNvSpPr txBox="1"/>
           <p:nvPr/>
         </p:nvSpPr>
@@ -16802,7 +16763,7 @@
       </p:sp>
       <p:sp>
         <p:nvSpPr>
-          <p:cNvPr id="15" name="obj268"/>
+          <p:cNvPr id="15" name="obj267"/>
           <p:cNvSpPr/>
           <p:nvPr/>
         </p:nvSpPr>
@@ -16824,7 +16785,7 @@
       </p:sp>
       <p:sp>
         <p:nvSpPr>
-          <p:cNvPr id="16" name="obj269"/>
+          <p:cNvPr id="16" name="obj268"/>
           <p:cNvSpPr txBox="1"/>
           <p:nvPr/>
         </p:nvSpPr>
@@ -16863,7 +16824,7 @@
       </p:sp>
       <p:sp>
         <p:nvSpPr>
-          <p:cNvPr id="17" name="obj270"/>
+          <p:cNvPr id="17" name="obj269"/>
           <p:cNvSpPr txBox="1"/>
           <p:nvPr/>
         </p:nvSpPr>
@@ -16902,7 +16863,7 @@
       </p:sp>
       <p:sp>
         <p:nvSpPr>
-          <p:cNvPr id="18" name="obj271"/>
+          <p:cNvPr id="18" name="obj270"/>
           <p:cNvSpPr txBox="1"/>
           <p:nvPr/>
         </p:nvSpPr>
@@ -16941,18 +16902,18 @@
       </p:sp>
       <p:sp>
         <p:nvSpPr>
-          <p:cNvPr id="19" name="obj272"/>
+          <p:cNvPr id="19" name="obj271"/>
           <p:cNvSpPr/>
           <p:nvPr/>
         </p:nvSpPr>
         <p:spPr>
           <a:xfrm>
             <a:off x="4663440" y="1097280"/>
-            <a:ext cx="3931920" cy="3429000"/>
+            <a:ext cx="3931920" cy="3337560"/>
           </a:xfrm>
           <a:prstGeom prst="roundRect">
             <a:avLst>
-              <a:gd name="adj" fmla="val 3733"/>
+              <a:gd name="adj" fmla="val 3836"/>
             </a:avLst>
           </a:prstGeom>
           <a:solidFill>
@@ -16963,7 +16924,7 @@
       </p:sp>
       <p:sp>
         <p:nvSpPr>
-          <p:cNvPr id="20" name="obj273"/>
+          <p:cNvPr id="20" name="obj272"/>
           <p:cNvSpPr txBox="1"/>
           <p:nvPr/>
         </p:nvSpPr>
@@ -17002,7 +16963,7 @@
       </p:sp>
       <p:sp>
         <p:nvSpPr>
-          <p:cNvPr id="21" name="obj274"/>
+          <p:cNvPr id="21" name="obj273"/>
           <p:cNvSpPr txBox="1"/>
           <p:nvPr/>
         </p:nvSpPr>
@@ -17041,13 +17002,13 @@
       </p:sp>
       <p:sp>
         <p:nvSpPr>
-          <p:cNvPr id="22" name="obj275"/>
+          <p:cNvPr id="22" name="obj274"/>
           <p:cNvSpPr txBox="1"/>
           <p:nvPr/>
         </p:nvSpPr>
         <p:spPr>
           <a:xfrm>
-            <a:off x="4892040" y="2148840"/>
+            <a:off x="4892040" y="2103120"/>
             <a:ext cx="411480" cy="228600"/>
           </a:xfrm>
           <a:prstGeom prst="rect">
@@ -17080,13 +17041,13 @@
       </p:sp>
       <p:sp>
         <p:nvSpPr>
-          <p:cNvPr id="23" name="obj276"/>
+          <p:cNvPr id="23" name="obj275"/>
           <p:cNvSpPr/>
           <p:nvPr/>
         </p:nvSpPr>
         <p:spPr>
           <a:xfrm>
-            <a:off x="5303520" y="2176272"/>
+            <a:off x="5303520" y="2130552"/>
             <a:ext cx="2400300" cy="182880"/>
           </a:xfrm>
           <a:prstGeom prst="roundRect">
@@ -17102,13 +17063,13 @@
       </p:sp>
       <p:sp>
         <p:nvSpPr>
-          <p:cNvPr id="24" name="obj277"/>
+          <p:cNvPr id="24" name="obj276"/>
           <p:cNvSpPr txBox="1"/>
           <p:nvPr/>
         </p:nvSpPr>
         <p:spPr>
           <a:xfrm>
-            <a:off x="7776972" y="2148840"/>
+            <a:off x="7776972" y="2103120"/>
             <a:ext cx="548640" cy="228600"/>
           </a:xfrm>
           <a:prstGeom prst="rect">
@@ -17141,13 +17102,13 @@
       </p:sp>
       <p:sp>
         <p:nvSpPr>
-          <p:cNvPr id="25" name="obj278"/>
+          <p:cNvPr id="25" name="obj277"/>
           <p:cNvSpPr txBox="1"/>
           <p:nvPr/>
         </p:nvSpPr>
         <p:spPr>
           <a:xfrm>
-            <a:off x="5303520" y="2386584"/>
+            <a:off x="5303520" y="2340864"/>
             <a:ext cx="3108960" cy="201168"/>
           </a:xfrm>
           <a:prstGeom prst="rect">
@@ -17180,13 +17141,13 @@
       </p:sp>
       <p:sp>
         <p:nvSpPr>
-          <p:cNvPr id="26" name="obj279"/>
+          <p:cNvPr id="26" name="obj278"/>
           <p:cNvSpPr txBox="1"/>
           <p:nvPr/>
         </p:nvSpPr>
         <p:spPr>
           <a:xfrm>
-            <a:off x="4892040" y="2697480"/>
+            <a:off x="4892040" y="2633472"/>
             <a:ext cx="411480" cy="228600"/>
           </a:xfrm>
           <a:prstGeom prst="rect">
@@ -17219,13 +17180,13 @@
       </p:sp>
       <p:sp>
         <p:nvSpPr>
-          <p:cNvPr id="27" name="obj280"/>
+          <p:cNvPr id="27" name="obj279"/>
           <p:cNvSpPr/>
           <p:nvPr/>
         </p:nvSpPr>
         <p:spPr>
           <a:xfrm>
-            <a:off x="5303520" y="2724912"/>
+            <a:off x="5303520" y="2660904"/>
             <a:ext cx="2743200" cy="182880"/>
           </a:xfrm>
           <a:prstGeom prst="roundRect">
@@ -17241,13 +17202,13 @@
       </p:sp>
       <p:sp>
         <p:nvSpPr>
-          <p:cNvPr id="28" name="obj281"/>
+          <p:cNvPr id="28" name="obj280"/>
           <p:cNvSpPr txBox="1"/>
           <p:nvPr/>
         </p:nvSpPr>
         <p:spPr>
           <a:xfrm>
-            <a:off x="8119872" y="2697480"/>
+            <a:off x="8119872" y="2633472"/>
             <a:ext cx="548640" cy="228600"/>
           </a:xfrm>
           <a:prstGeom prst="rect">
@@ -17280,13 +17241,13 @@
       </p:sp>
       <p:sp>
         <p:nvSpPr>
-          <p:cNvPr id="29" name="obj282"/>
+          <p:cNvPr id="29" name="obj281"/>
           <p:cNvSpPr txBox="1"/>
           <p:nvPr/>
         </p:nvSpPr>
         <p:spPr>
           <a:xfrm>
-            <a:off x="5303520" y="2935224"/>
+            <a:off x="5303520" y="2871216"/>
             <a:ext cx="3108960" cy="201168"/>
           </a:xfrm>
           <a:prstGeom prst="rect">
@@ -17319,13 +17280,13 @@
       </p:sp>
       <p:sp>
         <p:nvSpPr>
-          <p:cNvPr id="30" name="obj283"/>
+          <p:cNvPr id="30" name="obj282"/>
           <p:cNvSpPr txBox="1"/>
           <p:nvPr/>
         </p:nvSpPr>
         <p:spPr>
           <a:xfrm>
-            <a:off x="4892040" y="3246120"/>
+            <a:off x="4892040" y="3163824"/>
             <a:ext cx="411480" cy="228600"/>
           </a:xfrm>
           <a:prstGeom prst="rect">
@@ -17358,13 +17319,13 @@
       </p:sp>
       <p:sp>
         <p:nvSpPr>
-          <p:cNvPr id="31" name="obj284"/>
+          <p:cNvPr id="31" name="obj283"/>
           <p:cNvSpPr/>
           <p:nvPr/>
         </p:nvSpPr>
         <p:spPr>
           <a:xfrm>
-            <a:off x="5303520" y="3273552"/>
+            <a:off x="5303520" y="3191256"/>
             <a:ext cx="2743200" cy="182880"/>
           </a:xfrm>
           <a:prstGeom prst="roundRect">
@@ -17380,13 +17341,13 @@
       </p:sp>
       <p:sp>
         <p:nvSpPr>
-          <p:cNvPr id="32" name="obj285"/>
+          <p:cNvPr id="32" name="obj284"/>
           <p:cNvSpPr txBox="1"/>
           <p:nvPr/>
         </p:nvSpPr>
         <p:spPr>
           <a:xfrm>
-            <a:off x="8119872" y="3246120"/>
+            <a:off x="8119872" y="3163824"/>
             <a:ext cx="548640" cy="228600"/>
           </a:xfrm>
           <a:prstGeom prst="rect">
@@ -17419,13 +17380,13 @@
       </p:sp>
       <p:sp>
         <p:nvSpPr>
-          <p:cNvPr id="33" name="obj286"/>
+          <p:cNvPr id="33" name="obj285"/>
           <p:cNvSpPr txBox="1"/>
           <p:nvPr/>
         </p:nvSpPr>
         <p:spPr>
           <a:xfrm>
-            <a:off x="5303520" y="3483864"/>
+            <a:off x="5303520" y="3401568"/>
             <a:ext cx="3108960" cy="201168"/>
           </a:xfrm>
           <a:prstGeom prst="rect">
@@ -17458,13 +17419,13 @@
       </p:sp>
       <p:sp>
         <p:nvSpPr>
-          <p:cNvPr id="34" name="obj287"/>
+          <p:cNvPr id="34" name="obj286"/>
           <p:cNvSpPr txBox="1"/>
           <p:nvPr/>
         </p:nvSpPr>
         <p:spPr>
           <a:xfrm>
-            <a:off x="4892040" y="3794760"/>
+            <a:off x="4892040" y="3694176"/>
             <a:ext cx="411480" cy="228600"/>
           </a:xfrm>
           <a:prstGeom prst="rect">
@@ -17497,13 +17458,13 @@
       </p:sp>
       <p:sp>
         <p:nvSpPr>
-          <p:cNvPr id="35" name="obj288"/>
+          <p:cNvPr id="35" name="obj287"/>
           <p:cNvSpPr/>
           <p:nvPr/>
         </p:nvSpPr>
         <p:spPr>
           <a:xfrm>
-            <a:off x="5303520" y="3822192"/>
+            <a:off x="5303520" y="3721608"/>
             <a:ext cx="2743200" cy="182880"/>
           </a:xfrm>
           <a:prstGeom prst="roundRect">
@@ -17519,13 +17480,13 @@
       </p:sp>
       <p:sp>
         <p:nvSpPr>
-          <p:cNvPr id="36" name="obj289"/>
+          <p:cNvPr id="36" name="obj288"/>
           <p:cNvSpPr txBox="1"/>
           <p:nvPr/>
         </p:nvSpPr>
         <p:spPr>
           <a:xfrm>
-            <a:off x="8119872" y="3794760"/>
+            <a:off x="8119872" y="3694176"/>
             <a:ext cx="548640" cy="228600"/>
           </a:xfrm>
           <a:prstGeom prst="rect">
@@ -17558,13 +17519,13 @@
       </p:sp>
       <p:sp>
         <p:nvSpPr>
-          <p:cNvPr id="37" name="obj290"/>
+          <p:cNvPr id="37" name="obj289"/>
           <p:cNvSpPr txBox="1"/>
           <p:nvPr/>
         </p:nvSpPr>
         <p:spPr>
           <a:xfrm>
-            <a:off x="5303520" y="4032504"/>
+            <a:off x="5303520" y="3931920"/>
             <a:ext cx="3108960" cy="201168"/>
           </a:xfrm>
           <a:prstGeom prst="rect">
@@ -17597,13 +17558,13 @@
       </p:sp>
       <p:sp>
         <p:nvSpPr>
-          <p:cNvPr id="38" name="obj291"/>
+          <p:cNvPr id="38" name="obj290"/>
           <p:cNvSpPr txBox="1"/>
           <p:nvPr/>
         </p:nvSpPr>
         <p:spPr>
           <a:xfrm>
-            <a:off x="4892040" y="4315968"/>
+            <a:off x="4892040" y="4187952"/>
             <a:ext cx="3566160" cy="201168"/>
           </a:xfrm>
           <a:prstGeom prst="rect">
@@ -17636,13 +17597,13 @@
       </p:sp>
       <p:sp>
         <p:nvSpPr>
-          <p:cNvPr id="39" name="obj292"/>
+          <p:cNvPr id="39" name="obj291"/>
           <p:cNvSpPr txBox="1"/>
           <p:nvPr/>
         </p:nvSpPr>
         <p:spPr>
           <a:xfrm>
-            <a:off x="548640" y="4572000"/>
+            <a:off x="548640" y="4526280"/>
             <a:ext cx="8046720" cy="182880"/>
           </a:xfrm>
           <a:prstGeom prst="rect">

</xml_diff>